<commit_message>
Deploy advanced pitch deck: Qora_Pitch_Deck.pptx
</commit_message>
<xml_diff>
--- a/Qora_Pitch_Deck.pptx
+++ b/Qora_Pitch_Deck.pptx
@@ -135,7 +135,7 @@
           <p:cNvPr id="2" name="Title 1">
             <a:extLst>
               <a:ext uri="{FF2B5EF4-FFF2-40B4-BE49-F238E27FC236}">
-                <a16:creationId xmlns:a16="http://schemas.microsoft.com/office/drawing/2014/main" id="{818DF1DC-9B46-60C2-CCCD-224FE352A87B}"/>
+                <a16:creationId xmlns:a16="http://schemas.microsoft.com/office/drawing/2014/main" id="{AE331D86-BE25-CEFB-2A03-2CA6321AD496}"/>
               </a:ext>
             </a:extLst>
           </p:cNvPr>
@@ -173,7 +173,7 @@
           <p:cNvPr id="3" name="Subtitle 2">
             <a:extLst>
               <a:ext uri="{FF2B5EF4-FFF2-40B4-BE49-F238E27FC236}">
-                <a16:creationId xmlns:a16="http://schemas.microsoft.com/office/drawing/2014/main" id="{3876F6D1-FD50-1ED0-D6CD-9A7A2ADF0552}"/>
+                <a16:creationId xmlns:a16="http://schemas.microsoft.com/office/drawing/2014/main" id="{22E193D9-CE02-C261-A954-06D96BB387E5}"/>
               </a:ext>
             </a:extLst>
           </p:cNvPr>
@@ -244,7 +244,7 @@
           <p:cNvPr id="4" name="Date Placeholder 3">
             <a:extLst>
               <a:ext uri="{FF2B5EF4-FFF2-40B4-BE49-F238E27FC236}">
-                <a16:creationId xmlns:a16="http://schemas.microsoft.com/office/drawing/2014/main" id="{15211631-57FC-833C-FA36-7C3F3126901D}"/>
+                <a16:creationId xmlns:a16="http://schemas.microsoft.com/office/drawing/2014/main" id="{186ED22B-EDA7-A7A6-CA99-D5D1FEA3F7B7}"/>
               </a:ext>
             </a:extLst>
           </p:cNvPr>
@@ -260,7 +260,7 @@
           <a:bodyPr/>
           <a:lstStyle/>
           <a:p>
-            <a:fld id="{09A9739F-F1D6-4A09-9401-01D6C1617698}" type="datetimeFigureOut">
+            <a:fld id="{4416A6DF-60CD-44D2-B8D7-9C28A0EA7403}" type="datetimeFigureOut">
               <a:rPr lang="en-IN" smtClean="0"/>
               <a:t>16-09-2026</a:t>
             </a:fld>
@@ -273,7 +273,7 @@
           <p:cNvPr id="5" name="Footer Placeholder 4">
             <a:extLst>
               <a:ext uri="{FF2B5EF4-FFF2-40B4-BE49-F238E27FC236}">
-                <a16:creationId xmlns:a16="http://schemas.microsoft.com/office/drawing/2014/main" id="{D6558304-4CBE-884E-39C1-307D69335944}"/>
+                <a16:creationId xmlns:a16="http://schemas.microsoft.com/office/drawing/2014/main" id="{5D9E8D64-DB25-FF57-BA1C-6EF7E4C3A5E8}"/>
               </a:ext>
             </a:extLst>
           </p:cNvPr>
@@ -298,7 +298,7 @@
           <p:cNvPr id="6" name="Slide Number Placeholder 5">
             <a:extLst>
               <a:ext uri="{FF2B5EF4-FFF2-40B4-BE49-F238E27FC236}">
-                <a16:creationId xmlns:a16="http://schemas.microsoft.com/office/drawing/2014/main" id="{C5378DAD-FF52-6656-A43C-1FF9AAE6BDF0}"/>
+                <a16:creationId xmlns:a16="http://schemas.microsoft.com/office/drawing/2014/main" id="{CC658806-FB8A-CF95-22F6-AC0E91FBFF88}"/>
               </a:ext>
             </a:extLst>
           </p:cNvPr>
@@ -314,7 +314,7 @@
           <a:bodyPr/>
           <a:lstStyle/>
           <a:p>
-            <a:fld id="{D6C7D688-D6B0-499F-BF71-7CAA6C55BA1A}" type="slidenum">
+            <a:fld id="{78F6A441-4E7A-4D42-B657-3B8AA7E8D50A}" type="slidenum">
               <a:rPr lang="en-IN" smtClean="0"/>
               <a:t>‹#›</a:t>
             </a:fld>
@@ -325,7 +325,7 @@
     </p:spTree>
     <p:extLst>
       <p:ext uri="{BB962C8B-B14F-4D97-AF65-F5344CB8AC3E}">
-        <p14:creationId xmlns:p14="http://schemas.microsoft.com/office/powerpoint/2010/main" val="1980879028"/>
+        <p14:creationId xmlns:p14="http://schemas.microsoft.com/office/powerpoint/2010/main" val="1643598285"/>
       </p:ext>
     </p:extLst>
   </p:cSld>
@@ -357,7 +357,7 @@
           <p:cNvPr id="2" name="Title 1">
             <a:extLst>
               <a:ext uri="{FF2B5EF4-FFF2-40B4-BE49-F238E27FC236}">
-                <a16:creationId xmlns:a16="http://schemas.microsoft.com/office/drawing/2014/main" id="{28BBE3F2-3CC6-0687-1AF9-B2DB6B48DEE3}"/>
+                <a16:creationId xmlns:a16="http://schemas.microsoft.com/office/drawing/2014/main" id="{FA01FB6F-F1CB-D9AB-5D74-8681FD761004}"/>
               </a:ext>
             </a:extLst>
           </p:cNvPr>
@@ -386,7 +386,7 @@
           <p:cNvPr id="3" name="Vertical Text Placeholder 2">
             <a:extLst>
               <a:ext uri="{FF2B5EF4-FFF2-40B4-BE49-F238E27FC236}">
-                <a16:creationId xmlns:a16="http://schemas.microsoft.com/office/drawing/2014/main" id="{AB15CE79-6996-8F64-5A69-3FBD6BB61FF9}"/>
+                <a16:creationId xmlns:a16="http://schemas.microsoft.com/office/drawing/2014/main" id="{A2E289CB-2965-EF55-AB41-C9E58CE26396}"/>
               </a:ext>
             </a:extLst>
           </p:cNvPr>
@@ -444,7 +444,7 @@
           <p:cNvPr id="4" name="Date Placeholder 3">
             <a:extLst>
               <a:ext uri="{FF2B5EF4-FFF2-40B4-BE49-F238E27FC236}">
-                <a16:creationId xmlns:a16="http://schemas.microsoft.com/office/drawing/2014/main" id="{B8FF8864-A402-528A-A29D-F5F0C335045D}"/>
+                <a16:creationId xmlns:a16="http://schemas.microsoft.com/office/drawing/2014/main" id="{F78FCEF0-786F-96CC-EDF8-556340326A1F}"/>
               </a:ext>
             </a:extLst>
           </p:cNvPr>
@@ -460,7 +460,7 @@
           <a:bodyPr/>
           <a:lstStyle/>
           <a:p>
-            <a:fld id="{09A9739F-F1D6-4A09-9401-01D6C1617698}" type="datetimeFigureOut">
+            <a:fld id="{4416A6DF-60CD-44D2-B8D7-9C28A0EA7403}" type="datetimeFigureOut">
               <a:rPr lang="en-IN" smtClean="0"/>
               <a:t>16-09-2026</a:t>
             </a:fld>
@@ -473,7 +473,7 @@
           <p:cNvPr id="5" name="Footer Placeholder 4">
             <a:extLst>
               <a:ext uri="{FF2B5EF4-FFF2-40B4-BE49-F238E27FC236}">
-                <a16:creationId xmlns:a16="http://schemas.microsoft.com/office/drawing/2014/main" id="{B29EF707-2784-33CA-312C-CDDF3D5DCA28}"/>
+                <a16:creationId xmlns:a16="http://schemas.microsoft.com/office/drawing/2014/main" id="{1FF78BD0-B91F-290E-BCE5-A32FB257645A}"/>
               </a:ext>
             </a:extLst>
           </p:cNvPr>
@@ -498,7 +498,7 @@
           <p:cNvPr id="6" name="Slide Number Placeholder 5">
             <a:extLst>
               <a:ext uri="{FF2B5EF4-FFF2-40B4-BE49-F238E27FC236}">
-                <a16:creationId xmlns:a16="http://schemas.microsoft.com/office/drawing/2014/main" id="{BABA6568-12DE-5D7C-2643-66A6E46B9CEF}"/>
+                <a16:creationId xmlns:a16="http://schemas.microsoft.com/office/drawing/2014/main" id="{2CEC11E7-9990-75C7-98E8-62A47586C0A0}"/>
               </a:ext>
             </a:extLst>
           </p:cNvPr>
@@ -514,7 +514,7 @@
           <a:bodyPr/>
           <a:lstStyle/>
           <a:p>
-            <a:fld id="{D6C7D688-D6B0-499F-BF71-7CAA6C55BA1A}" type="slidenum">
+            <a:fld id="{78F6A441-4E7A-4D42-B657-3B8AA7E8D50A}" type="slidenum">
               <a:rPr lang="en-IN" smtClean="0"/>
               <a:t>‹#›</a:t>
             </a:fld>
@@ -525,7 +525,7 @@
     </p:spTree>
     <p:extLst>
       <p:ext uri="{BB962C8B-B14F-4D97-AF65-F5344CB8AC3E}">
-        <p14:creationId xmlns:p14="http://schemas.microsoft.com/office/powerpoint/2010/main" val="1730043495"/>
+        <p14:creationId xmlns:p14="http://schemas.microsoft.com/office/powerpoint/2010/main" val="961528872"/>
       </p:ext>
     </p:extLst>
   </p:cSld>
@@ -557,7 +557,7 @@
           <p:cNvPr id="2" name="Vertical Title 1">
             <a:extLst>
               <a:ext uri="{FF2B5EF4-FFF2-40B4-BE49-F238E27FC236}">
-                <a16:creationId xmlns:a16="http://schemas.microsoft.com/office/drawing/2014/main" id="{24774FEB-0998-7A50-13BA-EEEDCB7B02E4}"/>
+                <a16:creationId xmlns:a16="http://schemas.microsoft.com/office/drawing/2014/main" id="{3BC2054F-B881-8A86-1367-D50DBD0EA331}"/>
               </a:ext>
             </a:extLst>
           </p:cNvPr>
@@ -591,7 +591,7 @@
           <p:cNvPr id="3" name="Vertical Text Placeholder 2">
             <a:extLst>
               <a:ext uri="{FF2B5EF4-FFF2-40B4-BE49-F238E27FC236}">
-                <a16:creationId xmlns:a16="http://schemas.microsoft.com/office/drawing/2014/main" id="{50218E33-58B9-E460-1405-D16808689C6F}"/>
+                <a16:creationId xmlns:a16="http://schemas.microsoft.com/office/drawing/2014/main" id="{D8647D9B-F212-C98B-9033-73D8C9F08D22}"/>
               </a:ext>
             </a:extLst>
           </p:cNvPr>
@@ -654,7 +654,7 @@
           <p:cNvPr id="4" name="Date Placeholder 3">
             <a:extLst>
               <a:ext uri="{FF2B5EF4-FFF2-40B4-BE49-F238E27FC236}">
-                <a16:creationId xmlns:a16="http://schemas.microsoft.com/office/drawing/2014/main" id="{2C14A56F-3EA7-93DA-4900-38BC133CEEBE}"/>
+                <a16:creationId xmlns:a16="http://schemas.microsoft.com/office/drawing/2014/main" id="{72136AB0-959B-33F7-1477-B8EB0FFB0E0A}"/>
               </a:ext>
             </a:extLst>
           </p:cNvPr>
@@ -670,7 +670,7 @@
           <a:bodyPr/>
           <a:lstStyle/>
           <a:p>
-            <a:fld id="{09A9739F-F1D6-4A09-9401-01D6C1617698}" type="datetimeFigureOut">
+            <a:fld id="{4416A6DF-60CD-44D2-B8D7-9C28A0EA7403}" type="datetimeFigureOut">
               <a:rPr lang="en-IN" smtClean="0"/>
               <a:t>16-09-2026</a:t>
             </a:fld>
@@ -683,7 +683,7 @@
           <p:cNvPr id="5" name="Footer Placeholder 4">
             <a:extLst>
               <a:ext uri="{FF2B5EF4-FFF2-40B4-BE49-F238E27FC236}">
-                <a16:creationId xmlns:a16="http://schemas.microsoft.com/office/drawing/2014/main" id="{4710A09E-FC3F-BC16-7AFD-6CC040DE980A}"/>
+                <a16:creationId xmlns:a16="http://schemas.microsoft.com/office/drawing/2014/main" id="{87461387-2D89-E265-C28A-C0040E6D43EC}"/>
               </a:ext>
             </a:extLst>
           </p:cNvPr>
@@ -708,7 +708,7 @@
           <p:cNvPr id="6" name="Slide Number Placeholder 5">
             <a:extLst>
               <a:ext uri="{FF2B5EF4-FFF2-40B4-BE49-F238E27FC236}">
-                <a16:creationId xmlns:a16="http://schemas.microsoft.com/office/drawing/2014/main" id="{23325F7C-5369-135F-2925-2563D017EFFB}"/>
+                <a16:creationId xmlns:a16="http://schemas.microsoft.com/office/drawing/2014/main" id="{149C5776-DB88-6D96-566E-9B6D61455FE8}"/>
               </a:ext>
             </a:extLst>
           </p:cNvPr>
@@ -724,7 +724,7 @@
           <a:bodyPr/>
           <a:lstStyle/>
           <a:p>
-            <a:fld id="{D6C7D688-D6B0-499F-BF71-7CAA6C55BA1A}" type="slidenum">
+            <a:fld id="{78F6A441-4E7A-4D42-B657-3B8AA7E8D50A}" type="slidenum">
               <a:rPr lang="en-IN" smtClean="0"/>
               <a:t>‹#›</a:t>
             </a:fld>
@@ -735,7 +735,7 @@
     </p:spTree>
     <p:extLst>
       <p:ext uri="{BB962C8B-B14F-4D97-AF65-F5344CB8AC3E}">
-        <p14:creationId xmlns:p14="http://schemas.microsoft.com/office/powerpoint/2010/main" val="3405239606"/>
+        <p14:creationId xmlns:p14="http://schemas.microsoft.com/office/powerpoint/2010/main" val="174007801"/>
       </p:ext>
     </p:extLst>
   </p:cSld>
@@ -767,7 +767,7 @@
           <p:cNvPr id="2" name="Title 1">
             <a:extLst>
               <a:ext uri="{FF2B5EF4-FFF2-40B4-BE49-F238E27FC236}">
-                <a16:creationId xmlns:a16="http://schemas.microsoft.com/office/drawing/2014/main" id="{043672F4-7F50-6CDE-5414-8E4A9A52B39B}"/>
+                <a16:creationId xmlns:a16="http://schemas.microsoft.com/office/drawing/2014/main" id="{3F978C4C-7451-41E8-A8BC-2659A37C60F9}"/>
               </a:ext>
             </a:extLst>
           </p:cNvPr>
@@ -796,7 +796,7 @@
           <p:cNvPr id="3" name="Content Placeholder 2">
             <a:extLst>
               <a:ext uri="{FF2B5EF4-FFF2-40B4-BE49-F238E27FC236}">
-                <a16:creationId xmlns:a16="http://schemas.microsoft.com/office/drawing/2014/main" id="{92195DD9-BCB3-020B-5792-61DDDA1C3FFF}"/>
+                <a16:creationId xmlns:a16="http://schemas.microsoft.com/office/drawing/2014/main" id="{0806F02E-5866-AAD9-883F-B73E93F7F987}"/>
               </a:ext>
             </a:extLst>
           </p:cNvPr>
@@ -854,7 +854,7 @@
           <p:cNvPr id="4" name="Date Placeholder 3">
             <a:extLst>
               <a:ext uri="{FF2B5EF4-FFF2-40B4-BE49-F238E27FC236}">
-                <a16:creationId xmlns:a16="http://schemas.microsoft.com/office/drawing/2014/main" id="{4DF98016-C5CD-0158-9E2A-0D5C1EBBBEBC}"/>
+                <a16:creationId xmlns:a16="http://schemas.microsoft.com/office/drawing/2014/main" id="{6788B479-1D98-ABEA-243D-CFE841786C23}"/>
               </a:ext>
             </a:extLst>
           </p:cNvPr>
@@ -870,7 +870,7 @@
           <a:bodyPr/>
           <a:lstStyle/>
           <a:p>
-            <a:fld id="{09A9739F-F1D6-4A09-9401-01D6C1617698}" type="datetimeFigureOut">
+            <a:fld id="{4416A6DF-60CD-44D2-B8D7-9C28A0EA7403}" type="datetimeFigureOut">
               <a:rPr lang="en-IN" smtClean="0"/>
               <a:t>16-09-2026</a:t>
             </a:fld>
@@ -883,7 +883,7 @@
           <p:cNvPr id="5" name="Footer Placeholder 4">
             <a:extLst>
               <a:ext uri="{FF2B5EF4-FFF2-40B4-BE49-F238E27FC236}">
-                <a16:creationId xmlns:a16="http://schemas.microsoft.com/office/drawing/2014/main" id="{494AAA51-9B76-DF19-61F4-A944D0CDE42C}"/>
+                <a16:creationId xmlns:a16="http://schemas.microsoft.com/office/drawing/2014/main" id="{19F78120-9BDB-4755-68D2-B21D9C704637}"/>
               </a:ext>
             </a:extLst>
           </p:cNvPr>
@@ -908,7 +908,7 @@
           <p:cNvPr id="6" name="Slide Number Placeholder 5">
             <a:extLst>
               <a:ext uri="{FF2B5EF4-FFF2-40B4-BE49-F238E27FC236}">
-                <a16:creationId xmlns:a16="http://schemas.microsoft.com/office/drawing/2014/main" id="{971AF725-AC23-E798-452F-DF494FFF9C64}"/>
+                <a16:creationId xmlns:a16="http://schemas.microsoft.com/office/drawing/2014/main" id="{58C8D5E6-31D2-ACB8-E91B-B1A45789A366}"/>
               </a:ext>
             </a:extLst>
           </p:cNvPr>
@@ -924,7 +924,7 @@
           <a:bodyPr/>
           <a:lstStyle/>
           <a:p>
-            <a:fld id="{D6C7D688-D6B0-499F-BF71-7CAA6C55BA1A}" type="slidenum">
+            <a:fld id="{78F6A441-4E7A-4D42-B657-3B8AA7E8D50A}" type="slidenum">
               <a:rPr lang="en-IN" smtClean="0"/>
               <a:t>‹#›</a:t>
             </a:fld>
@@ -935,7 +935,7 @@
     </p:spTree>
     <p:extLst>
       <p:ext uri="{BB962C8B-B14F-4D97-AF65-F5344CB8AC3E}">
-        <p14:creationId xmlns:p14="http://schemas.microsoft.com/office/powerpoint/2010/main" val="506019930"/>
+        <p14:creationId xmlns:p14="http://schemas.microsoft.com/office/powerpoint/2010/main" val="3466748157"/>
       </p:ext>
     </p:extLst>
   </p:cSld>
@@ -967,7 +967,7 @@
           <p:cNvPr id="2" name="Title 1">
             <a:extLst>
               <a:ext uri="{FF2B5EF4-FFF2-40B4-BE49-F238E27FC236}">
-                <a16:creationId xmlns:a16="http://schemas.microsoft.com/office/drawing/2014/main" id="{330BD3D8-50C8-E774-9A0E-EDFEB0D817FA}"/>
+                <a16:creationId xmlns:a16="http://schemas.microsoft.com/office/drawing/2014/main" id="{2A69ED34-5058-B332-106A-B633A9FC9D5B}"/>
               </a:ext>
             </a:extLst>
           </p:cNvPr>
@@ -1005,7 +1005,7 @@
           <p:cNvPr id="3" name="Text Placeholder 2">
             <a:extLst>
               <a:ext uri="{FF2B5EF4-FFF2-40B4-BE49-F238E27FC236}">
-                <a16:creationId xmlns:a16="http://schemas.microsoft.com/office/drawing/2014/main" id="{E5CA2276-562E-5EDD-F605-0F1A110A2418}"/>
+                <a16:creationId xmlns:a16="http://schemas.microsoft.com/office/drawing/2014/main" id="{0D6C8C4C-43EC-3A6E-D443-48F85DEEBD73}"/>
               </a:ext>
             </a:extLst>
           </p:cNvPr>
@@ -1130,7 +1130,7 @@
           <p:cNvPr id="4" name="Date Placeholder 3">
             <a:extLst>
               <a:ext uri="{FF2B5EF4-FFF2-40B4-BE49-F238E27FC236}">
-                <a16:creationId xmlns:a16="http://schemas.microsoft.com/office/drawing/2014/main" id="{BE36BF00-B9AA-CEC2-F7D1-7F7CE04F16AE}"/>
+                <a16:creationId xmlns:a16="http://schemas.microsoft.com/office/drawing/2014/main" id="{5E6E2461-39CF-C82C-76CE-06B68F2CD0C2}"/>
               </a:ext>
             </a:extLst>
           </p:cNvPr>
@@ -1146,7 +1146,7 @@
           <a:bodyPr/>
           <a:lstStyle/>
           <a:p>
-            <a:fld id="{09A9739F-F1D6-4A09-9401-01D6C1617698}" type="datetimeFigureOut">
+            <a:fld id="{4416A6DF-60CD-44D2-B8D7-9C28A0EA7403}" type="datetimeFigureOut">
               <a:rPr lang="en-IN" smtClean="0"/>
               <a:t>16-09-2026</a:t>
             </a:fld>
@@ -1159,7 +1159,7 @@
           <p:cNvPr id="5" name="Footer Placeholder 4">
             <a:extLst>
               <a:ext uri="{FF2B5EF4-FFF2-40B4-BE49-F238E27FC236}">
-                <a16:creationId xmlns:a16="http://schemas.microsoft.com/office/drawing/2014/main" id="{83603BD1-7686-09A8-D7B4-94529E6C6515}"/>
+                <a16:creationId xmlns:a16="http://schemas.microsoft.com/office/drawing/2014/main" id="{D31A7BEC-57C7-4AD4-2730-7A163AA5B8F6}"/>
               </a:ext>
             </a:extLst>
           </p:cNvPr>
@@ -1184,7 +1184,7 @@
           <p:cNvPr id="6" name="Slide Number Placeholder 5">
             <a:extLst>
               <a:ext uri="{FF2B5EF4-FFF2-40B4-BE49-F238E27FC236}">
-                <a16:creationId xmlns:a16="http://schemas.microsoft.com/office/drawing/2014/main" id="{4BA6A666-C96D-35C2-0BDE-C84AC970F3DC}"/>
+                <a16:creationId xmlns:a16="http://schemas.microsoft.com/office/drawing/2014/main" id="{C8B184E9-B4BD-142E-CA77-FC69AD82C87B}"/>
               </a:ext>
             </a:extLst>
           </p:cNvPr>
@@ -1200,7 +1200,7 @@
           <a:bodyPr/>
           <a:lstStyle/>
           <a:p>
-            <a:fld id="{D6C7D688-D6B0-499F-BF71-7CAA6C55BA1A}" type="slidenum">
+            <a:fld id="{78F6A441-4E7A-4D42-B657-3B8AA7E8D50A}" type="slidenum">
               <a:rPr lang="en-IN" smtClean="0"/>
               <a:t>‹#›</a:t>
             </a:fld>
@@ -1211,7 +1211,7 @@
     </p:spTree>
     <p:extLst>
       <p:ext uri="{BB962C8B-B14F-4D97-AF65-F5344CB8AC3E}">
-        <p14:creationId xmlns:p14="http://schemas.microsoft.com/office/powerpoint/2010/main" val="541166117"/>
+        <p14:creationId xmlns:p14="http://schemas.microsoft.com/office/powerpoint/2010/main" val="1182768736"/>
       </p:ext>
     </p:extLst>
   </p:cSld>
@@ -1243,7 +1243,7 @@
           <p:cNvPr id="2" name="Title 1">
             <a:extLst>
               <a:ext uri="{FF2B5EF4-FFF2-40B4-BE49-F238E27FC236}">
-                <a16:creationId xmlns:a16="http://schemas.microsoft.com/office/drawing/2014/main" id="{12CCA026-D4B8-95FA-1FDA-10FBDAC1211B}"/>
+                <a16:creationId xmlns:a16="http://schemas.microsoft.com/office/drawing/2014/main" id="{B0B6619B-5EAC-BF6D-A52C-E8DA68018F7E}"/>
               </a:ext>
             </a:extLst>
           </p:cNvPr>
@@ -1272,7 +1272,7 @@
           <p:cNvPr id="3" name="Content Placeholder 2">
             <a:extLst>
               <a:ext uri="{FF2B5EF4-FFF2-40B4-BE49-F238E27FC236}">
-                <a16:creationId xmlns:a16="http://schemas.microsoft.com/office/drawing/2014/main" id="{333876F6-6E0D-211F-387B-5D125227DA8D}"/>
+                <a16:creationId xmlns:a16="http://schemas.microsoft.com/office/drawing/2014/main" id="{E35AE98C-B331-C543-0E5C-1CB9903EBFF4}"/>
               </a:ext>
             </a:extLst>
           </p:cNvPr>
@@ -1335,7 +1335,7 @@
           <p:cNvPr id="4" name="Content Placeholder 3">
             <a:extLst>
               <a:ext uri="{FF2B5EF4-FFF2-40B4-BE49-F238E27FC236}">
-                <a16:creationId xmlns:a16="http://schemas.microsoft.com/office/drawing/2014/main" id="{CF0B75DD-A827-7205-0B4E-86558811CD5F}"/>
+                <a16:creationId xmlns:a16="http://schemas.microsoft.com/office/drawing/2014/main" id="{AA3B9386-1F02-EA61-4B54-C19E834D98E1}"/>
               </a:ext>
             </a:extLst>
           </p:cNvPr>
@@ -1398,7 +1398,7 @@
           <p:cNvPr id="5" name="Date Placeholder 4">
             <a:extLst>
               <a:ext uri="{FF2B5EF4-FFF2-40B4-BE49-F238E27FC236}">
-                <a16:creationId xmlns:a16="http://schemas.microsoft.com/office/drawing/2014/main" id="{D4F1D990-980F-836A-A55C-E93BC4A8EA31}"/>
+                <a16:creationId xmlns:a16="http://schemas.microsoft.com/office/drawing/2014/main" id="{E95BE431-29AF-8467-797E-1417E5E49109}"/>
               </a:ext>
             </a:extLst>
           </p:cNvPr>
@@ -1414,7 +1414,7 @@
           <a:bodyPr/>
           <a:lstStyle/>
           <a:p>
-            <a:fld id="{09A9739F-F1D6-4A09-9401-01D6C1617698}" type="datetimeFigureOut">
+            <a:fld id="{4416A6DF-60CD-44D2-B8D7-9C28A0EA7403}" type="datetimeFigureOut">
               <a:rPr lang="en-IN" smtClean="0"/>
               <a:t>16-09-2026</a:t>
             </a:fld>
@@ -1427,7 +1427,7 @@
           <p:cNvPr id="6" name="Footer Placeholder 5">
             <a:extLst>
               <a:ext uri="{FF2B5EF4-FFF2-40B4-BE49-F238E27FC236}">
-                <a16:creationId xmlns:a16="http://schemas.microsoft.com/office/drawing/2014/main" id="{3C1FBD31-A716-222E-8A40-AE763328AE87}"/>
+                <a16:creationId xmlns:a16="http://schemas.microsoft.com/office/drawing/2014/main" id="{D7C7FCF6-7D1B-C18E-DD9D-6961EF65D45C}"/>
               </a:ext>
             </a:extLst>
           </p:cNvPr>
@@ -1452,7 +1452,7 @@
           <p:cNvPr id="7" name="Slide Number Placeholder 6">
             <a:extLst>
               <a:ext uri="{FF2B5EF4-FFF2-40B4-BE49-F238E27FC236}">
-                <a16:creationId xmlns:a16="http://schemas.microsoft.com/office/drawing/2014/main" id="{6574BF0D-06A0-3BD7-9FC9-D1949D8C7DA5}"/>
+                <a16:creationId xmlns:a16="http://schemas.microsoft.com/office/drawing/2014/main" id="{D23C411B-8031-A00E-EE3A-FA1B1AE98F87}"/>
               </a:ext>
             </a:extLst>
           </p:cNvPr>
@@ -1468,7 +1468,7 @@
           <a:bodyPr/>
           <a:lstStyle/>
           <a:p>
-            <a:fld id="{D6C7D688-D6B0-499F-BF71-7CAA6C55BA1A}" type="slidenum">
+            <a:fld id="{78F6A441-4E7A-4D42-B657-3B8AA7E8D50A}" type="slidenum">
               <a:rPr lang="en-IN" smtClean="0"/>
               <a:t>‹#›</a:t>
             </a:fld>
@@ -1479,7 +1479,7 @@
     </p:spTree>
     <p:extLst>
       <p:ext uri="{BB962C8B-B14F-4D97-AF65-F5344CB8AC3E}">
-        <p14:creationId xmlns:p14="http://schemas.microsoft.com/office/powerpoint/2010/main" val="1899608259"/>
+        <p14:creationId xmlns:p14="http://schemas.microsoft.com/office/powerpoint/2010/main" val="2795033478"/>
       </p:ext>
     </p:extLst>
   </p:cSld>
@@ -1511,7 +1511,7 @@
           <p:cNvPr id="2" name="Title 1">
             <a:extLst>
               <a:ext uri="{FF2B5EF4-FFF2-40B4-BE49-F238E27FC236}">
-                <a16:creationId xmlns:a16="http://schemas.microsoft.com/office/drawing/2014/main" id="{C96D4922-AAA1-F39F-B6A6-8C80BE15559C}"/>
+                <a16:creationId xmlns:a16="http://schemas.microsoft.com/office/drawing/2014/main" id="{5B8912E4-3C88-A92A-4A02-99A84AC77CF9}"/>
               </a:ext>
             </a:extLst>
           </p:cNvPr>
@@ -1545,7 +1545,7 @@
           <p:cNvPr id="3" name="Text Placeholder 2">
             <a:extLst>
               <a:ext uri="{FF2B5EF4-FFF2-40B4-BE49-F238E27FC236}">
-                <a16:creationId xmlns:a16="http://schemas.microsoft.com/office/drawing/2014/main" id="{21EE8CA0-6B79-F361-A337-B64D6E1151FE}"/>
+                <a16:creationId xmlns:a16="http://schemas.microsoft.com/office/drawing/2014/main" id="{A749C749-D8DD-3259-42E5-5CDA14AE46A6}"/>
               </a:ext>
             </a:extLst>
           </p:cNvPr>
@@ -1616,7 +1616,7 @@
           <p:cNvPr id="4" name="Content Placeholder 3">
             <a:extLst>
               <a:ext uri="{FF2B5EF4-FFF2-40B4-BE49-F238E27FC236}">
-                <a16:creationId xmlns:a16="http://schemas.microsoft.com/office/drawing/2014/main" id="{ACB79BD6-7D29-AC36-984A-8E260D951214}"/>
+                <a16:creationId xmlns:a16="http://schemas.microsoft.com/office/drawing/2014/main" id="{B0C16441-E601-803D-D94B-7E49F6A4830D}"/>
               </a:ext>
             </a:extLst>
           </p:cNvPr>
@@ -1679,7 +1679,7 @@
           <p:cNvPr id="5" name="Text Placeholder 4">
             <a:extLst>
               <a:ext uri="{FF2B5EF4-FFF2-40B4-BE49-F238E27FC236}">
-                <a16:creationId xmlns:a16="http://schemas.microsoft.com/office/drawing/2014/main" id="{03651678-34A2-4E08-7137-4FB8CC074F93}"/>
+                <a16:creationId xmlns:a16="http://schemas.microsoft.com/office/drawing/2014/main" id="{F560DE51-93D8-8022-2B9B-D1248EDE6EEC}"/>
               </a:ext>
             </a:extLst>
           </p:cNvPr>
@@ -1750,7 +1750,7 @@
           <p:cNvPr id="6" name="Content Placeholder 5">
             <a:extLst>
               <a:ext uri="{FF2B5EF4-FFF2-40B4-BE49-F238E27FC236}">
-                <a16:creationId xmlns:a16="http://schemas.microsoft.com/office/drawing/2014/main" id="{C6FF2990-4F7F-01CC-208A-B9E7A759BF55}"/>
+                <a16:creationId xmlns:a16="http://schemas.microsoft.com/office/drawing/2014/main" id="{96BE7716-E221-4881-A858-B3E6024BA2FF}"/>
               </a:ext>
             </a:extLst>
           </p:cNvPr>
@@ -1813,7 +1813,7 @@
           <p:cNvPr id="7" name="Date Placeholder 6">
             <a:extLst>
               <a:ext uri="{FF2B5EF4-FFF2-40B4-BE49-F238E27FC236}">
-                <a16:creationId xmlns:a16="http://schemas.microsoft.com/office/drawing/2014/main" id="{4699609A-9E3D-DA26-02CC-354418C4F25D}"/>
+                <a16:creationId xmlns:a16="http://schemas.microsoft.com/office/drawing/2014/main" id="{C976AB88-9FDE-B2DD-B292-900012710DCA}"/>
               </a:ext>
             </a:extLst>
           </p:cNvPr>
@@ -1829,7 +1829,7 @@
           <a:bodyPr/>
           <a:lstStyle/>
           <a:p>
-            <a:fld id="{09A9739F-F1D6-4A09-9401-01D6C1617698}" type="datetimeFigureOut">
+            <a:fld id="{4416A6DF-60CD-44D2-B8D7-9C28A0EA7403}" type="datetimeFigureOut">
               <a:rPr lang="en-IN" smtClean="0"/>
               <a:t>16-09-2026</a:t>
             </a:fld>
@@ -1842,7 +1842,7 @@
           <p:cNvPr id="8" name="Footer Placeholder 7">
             <a:extLst>
               <a:ext uri="{FF2B5EF4-FFF2-40B4-BE49-F238E27FC236}">
-                <a16:creationId xmlns:a16="http://schemas.microsoft.com/office/drawing/2014/main" id="{161C339A-A648-F074-D4CB-6FFC059BD46F}"/>
+                <a16:creationId xmlns:a16="http://schemas.microsoft.com/office/drawing/2014/main" id="{80CB0BBC-937D-F7C5-ED4B-A3870D059479}"/>
               </a:ext>
             </a:extLst>
           </p:cNvPr>
@@ -1867,7 +1867,7 @@
           <p:cNvPr id="9" name="Slide Number Placeholder 8">
             <a:extLst>
               <a:ext uri="{FF2B5EF4-FFF2-40B4-BE49-F238E27FC236}">
-                <a16:creationId xmlns:a16="http://schemas.microsoft.com/office/drawing/2014/main" id="{BEA27C11-418C-D705-BE14-850A2D10E547}"/>
+                <a16:creationId xmlns:a16="http://schemas.microsoft.com/office/drawing/2014/main" id="{D89AD8C0-514C-FF42-6673-A9176C0FC910}"/>
               </a:ext>
             </a:extLst>
           </p:cNvPr>
@@ -1883,7 +1883,7 @@
           <a:bodyPr/>
           <a:lstStyle/>
           <a:p>
-            <a:fld id="{D6C7D688-D6B0-499F-BF71-7CAA6C55BA1A}" type="slidenum">
+            <a:fld id="{78F6A441-4E7A-4D42-B657-3B8AA7E8D50A}" type="slidenum">
               <a:rPr lang="en-IN" smtClean="0"/>
               <a:t>‹#›</a:t>
             </a:fld>
@@ -1894,7 +1894,7 @@
     </p:spTree>
     <p:extLst>
       <p:ext uri="{BB962C8B-B14F-4D97-AF65-F5344CB8AC3E}">
-        <p14:creationId xmlns:p14="http://schemas.microsoft.com/office/powerpoint/2010/main" val="1791027703"/>
+        <p14:creationId xmlns:p14="http://schemas.microsoft.com/office/powerpoint/2010/main" val="3002669140"/>
       </p:ext>
     </p:extLst>
   </p:cSld>
@@ -1926,7 +1926,7 @@
           <p:cNvPr id="2" name="Title 1">
             <a:extLst>
               <a:ext uri="{FF2B5EF4-FFF2-40B4-BE49-F238E27FC236}">
-                <a16:creationId xmlns:a16="http://schemas.microsoft.com/office/drawing/2014/main" id="{47422698-8ED0-ABEF-16F1-ACDA75AA82F6}"/>
+                <a16:creationId xmlns:a16="http://schemas.microsoft.com/office/drawing/2014/main" id="{DAED0D50-08D6-7F26-1E19-4CC8A2C126D4}"/>
               </a:ext>
             </a:extLst>
           </p:cNvPr>
@@ -1955,7 +1955,7 @@
           <p:cNvPr id="3" name="Date Placeholder 2">
             <a:extLst>
               <a:ext uri="{FF2B5EF4-FFF2-40B4-BE49-F238E27FC236}">
-                <a16:creationId xmlns:a16="http://schemas.microsoft.com/office/drawing/2014/main" id="{2D610760-E9D5-2BED-8585-DC74359B4001}"/>
+                <a16:creationId xmlns:a16="http://schemas.microsoft.com/office/drawing/2014/main" id="{2CFAF460-0D4C-0762-89D9-049905A1477A}"/>
               </a:ext>
             </a:extLst>
           </p:cNvPr>
@@ -1971,7 +1971,7 @@
           <a:bodyPr/>
           <a:lstStyle/>
           <a:p>
-            <a:fld id="{09A9739F-F1D6-4A09-9401-01D6C1617698}" type="datetimeFigureOut">
+            <a:fld id="{4416A6DF-60CD-44D2-B8D7-9C28A0EA7403}" type="datetimeFigureOut">
               <a:rPr lang="en-IN" smtClean="0"/>
               <a:t>16-09-2026</a:t>
             </a:fld>
@@ -1984,7 +1984,7 @@
           <p:cNvPr id="4" name="Footer Placeholder 3">
             <a:extLst>
               <a:ext uri="{FF2B5EF4-FFF2-40B4-BE49-F238E27FC236}">
-                <a16:creationId xmlns:a16="http://schemas.microsoft.com/office/drawing/2014/main" id="{F5391E27-D2B6-1ECA-4C74-3A947201A7E7}"/>
+                <a16:creationId xmlns:a16="http://schemas.microsoft.com/office/drawing/2014/main" id="{239286A0-5B83-BC5C-B893-1BA79B9F1E7D}"/>
               </a:ext>
             </a:extLst>
           </p:cNvPr>
@@ -2009,7 +2009,7 @@
           <p:cNvPr id="5" name="Slide Number Placeholder 4">
             <a:extLst>
               <a:ext uri="{FF2B5EF4-FFF2-40B4-BE49-F238E27FC236}">
-                <a16:creationId xmlns:a16="http://schemas.microsoft.com/office/drawing/2014/main" id="{F0C00A85-1AFA-C173-C8DD-829AACB91FAB}"/>
+                <a16:creationId xmlns:a16="http://schemas.microsoft.com/office/drawing/2014/main" id="{066F9CCE-77A5-5C46-6353-440A1D8E3A88}"/>
               </a:ext>
             </a:extLst>
           </p:cNvPr>
@@ -2025,7 +2025,7 @@
           <a:bodyPr/>
           <a:lstStyle/>
           <a:p>
-            <a:fld id="{D6C7D688-D6B0-499F-BF71-7CAA6C55BA1A}" type="slidenum">
+            <a:fld id="{78F6A441-4E7A-4D42-B657-3B8AA7E8D50A}" type="slidenum">
               <a:rPr lang="en-IN" smtClean="0"/>
               <a:t>‹#›</a:t>
             </a:fld>
@@ -2036,7 +2036,7 @@
     </p:spTree>
     <p:extLst>
       <p:ext uri="{BB962C8B-B14F-4D97-AF65-F5344CB8AC3E}">
-        <p14:creationId xmlns:p14="http://schemas.microsoft.com/office/powerpoint/2010/main" val="1830492778"/>
+        <p14:creationId xmlns:p14="http://schemas.microsoft.com/office/powerpoint/2010/main" val="1696495882"/>
       </p:ext>
     </p:extLst>
   </p:cSld>
@@ -2068,7 +2068,7 @@
           <p:cNvPr id="2" name="Date Placeholder 1">
             <a:extLst>
               <a:ext uri="{FF2B5EF4-FFF2-40B4-BE49-F238E27FC236}">
-                <a16:creationId xmlns:a16="http://schemas.microsoft.com/office/drawing/2014/main" id="{38961EC1-9B77-92A1-4B12-7C8D8B9207F5}"/>
+                <a16:creationId xmlns:a16="http://schemas.microsoft.com/office/drawing/2014/main" id="{34B9F403-78A2-2C1A-DE81-45BE4AD648C4}"/>
               </a:ext>
             </a:extLst>
           </p:cNvPr>
@@ -2084,7 +2084,7 @@
           <a:bodyPr/>
           <a:lstStyle/>
           <a:p>
-            <a:fld id="{09A9739F-F1D6-4A09-9401-01D6C1617698}" type="datetimeFigureOut">
+            <a:fld id="{4416A6DF-60CD-44D2-B8D7-9C28A0EA7403}" type="datetimeFigureOut">
               <a:rPr lang="en-IN" smtClean="0"/>
               <a:t>16-09-2026</a:t>
             </a:fld>
@@ -2097,7 +2097,7 @@
           <p:cNvPr id="3" name="Footer Placeholder 2">
             <a:extLst>
               <a:ext uri="{FF2B5EF4-FFF2-40B4-BE49-F238E27FC236}">
-                <a16:creationId xmlns:a16="http://schemas.microsoft.com/office/drawing/2014/main" id="{CB36E5AC-4D14-249F-5EA9-B73344E992B9}"/>
+                <a16:creationId xmlns:a16="http://schemas.microsoft.com/office/drawing/2014/main" id="{032CC04E-EE57-8A30-D001-CC32E0A68C49}"/>
               </a:ext>
             </a:extLst>
           </p:cNvPr>
@@ -2122,7 +2122,7 @@
           <p:cNvPr id="4" name="Slide Number Placeholder 3">
             <a:extLst>
               <a:ext uri="{FF2B5EF4-FFF2-40B4-BE49-F238E27FC236}">
-                <a16:creationId xmlns:a16="http://schemas.microsoft.com/office/drawing/2014/main" id="{81EEF17C-C637-251D-0418-C02E7AC3598D}"/>
+                <a16:creationId xmlns:a16="http://schemas.microsoft.com/office/drawing/2014/main" id="{73D3AAAD-9E52-F243-9660-63A4155A388C}"/>
               </a:ext>
             </a:extLst>
           </p:cNvPr>
@@ -2138,7 +2138,7 @@
           <a:bodyPr/>
           <a:lstStyle/>
           <a:p>
-            <a:fld id="{D6C7D688-D6B0-499F-BF71-7CAA6C55BA1A}" type="slidenum">
+            <a:fld id="{78F6A441-4E7A-4D42-B657-3B8AA7E8D50A}" type="slidenum">
               <a:rPr lang="en-IN" smtClean="0"/>
               <a:t>‹#›</a:t>
             </a:fld>
@@ -2149,7 +2149,7 @@
     </p:spTree>
     <p:extLst>
       <p:ext uri="{BB962C8B-B14F-4D97-AF65-F5344CB8AC3E}">
-        <p14:creationId xmlns:p14="http://schemas.microsoft.com/office/powerpoint/2010/main" val="413320846"/>
+        <p14:creationId xmlns:p14="http://schemas.microsoft.com/office/powerpoint/2010/main" val="1771918912"/>
       </p:ext>
     </p:extLst>
   </p:cSld>
@@ -2181,7 +2181,7 @@
           <p:cNvPr id="2" name="Title 1">
             <a:extLst>
               <a:ext uri="{FF2B5EF4-FFF2-40B4-BE49-F238E27FC236}">
-                <a16:creationId xmlns:a16="http://schemas.microsoft.com/office/drawing/2014/main" id="{3FF52626-38B9-A5CD-9903-E90E85D234AB}"/>
+                <a16:creationId xmlns:a16="http://schemas.microsoft.com/office/drawing/2014/main" id="{BB03A59E-844E-6EAB-8F78-76D0F395CE83}"/>
               </a:ext>
             </a:extLst>
           </p:cNvPr>
@@ -2219,7 +2219,7 @@
           <p:cNvPr id="3" name="Content Placeholder 2">
             <a:extLst>
               <a:ext uri="{FF2B5EF4-FFF2-40B4-BE49-F238E27FC236}">
-                <a16:creationId xmlns:a16="http://schemas.microsoft.com/office/drawing/2014/main" id="{1D1EDED6-695A-5F0D-FEAF-577719AF90C6}"/>
+                <a16:creationId xmlns:a16="http://schemas.microsoft.com/office/drawing/2014/main" id="{E0023CD4-2584-6963-00FF-9F60BF204908}"/>
               </a:ext>
             </a:extLst>
           </p:cNvPr>
@@ -2310,7 +2310,7 @@
           <p:cNvPr id="4" name="Text Placeholder 3">
             <a:extLst>
               <a:ext uri="{FF2B5EF4-FFF2-40B4-BE49-F238E27FC236}">
-                <a16:creationId xmlns:a16="http://schemas.microsoft.com/office/drawing/2014/main" id="{96197F19-8300-0D23-DA65-9E4279FEF44F}"/>
+                <a16:creationId xmlns:a16="http://schemas.microsoft.com/office/drawing/2014/main" id="{B5667B87-910C-47BB-FDAF-F5CA69D57838}"/>
               </a:ext>
             </a:extLst>
           </p:cNvPr>
@@ -2381,7 +2381,7 @@
           <p:cNvPr id="5" name="Date Placeholder 4">
             <a:extLst>
               <a:ext uri="{FF2B5EF4-FFF2-40B4-BE49-F238E27FC236}">
-                <a16:creationId xmlns:a16="http://schemas.microsoft.com/office/drawing/2014/main" id="{0A7B1867-F4A1-0C9E-3937-749CCA77EA39}"/>
+                <a16:creationId xmlns:a16="http://schemas.microsoft.com/office/drawing/2014/main" id="{C8241BE0-E0BB-130F-A1A6-E5C318C8FCF7}"/>
               </a:ext>
             </a:extLst>
           </p:cNvPr>
@@ -2397,7 +2397,7 @@
           <a:bodyPr/>
           <a:lstStyle/>
           <a:p>
-            <a:fld id="{09A9739F-F1D6-4A09-9401-01D6C1617698}" type="datetimeFigureOut">
+            <a:fld id="{4416A6DF-60CD-44D2-B8D7-9C28A0EA7403}" type="datetimeFigureOut">
               <a:rPr lang="en-IN" smtClean="0"/>
               <a:t>16-09-2026</a:t>
             </a:fld>
@@ -2410,7 +2410,7 @@
           <p:cNvPr id="6" name="Footer Placeholder 5">
             <a:extLst>
               <a:ext uri="{FF2B5EF4-FFF2-40B4-BE49-F238E27FC236}">
-                <a16:creationId xmlns:a16="http://schemas.microsoft.com/office/drawing/2014/main" id="{B8BC4521-F473-4EDB-5282-4092806A6A99}"/>
+                <a16:creationId xmlns:a16="http://schemas.microsoft.com/office/drawing/2014/main" id="{3CC83E14-1014-4E47-75CD-A21E5AFCD2F7}"/>
               </a:ext>
             </a:extLst>
           </p:cNvPr>
@@ -2435,7 +2435,7 @@
           <p:cNvPr id="7" name="Slide Number Placeholder 6">
             <a:extLst>
               <a:ext uri="{FF2B5EF4-FFF2-40B4-BE49-F238E27FC236}">
-                <a16:creationId xmlns:a16="http://schemas.microsoft.com/office/drawing/2014/main" id="{85BED3A4-82BE-3B31-A3A5-92DE97AD3C55}"/>
+                <a16:creationId xmlns:a16="http://schemas.microsoft.com/office/drawing/2014/main" id="{BE903AE9-D29F-0201-1329-C6A69FE04449}"/>
               </a:ext>
             </a:extLst>
           </p:cNvPr>
@@ -2451,7 +2451,7 @@
           <a:bodyPr/>
           <a:lstStyle/>
           <a:p>
-            <a:fld id="{D6C7D688-D6B0-499F-BF71-7CAA6C55BA1A}" type="slidenum">
+            <a:fld id="{78F6A441-4E7A-4D42-B657-3B8AA7E8D50A}" type="slidenum">
               <a:rPr lang="en-IN" smtClean="0"/>
               <a:t>‹#›</a:t>
             </a:fld>
@@ -2462,7 +2462,7 @@
     </p:spTree>
     <p:extLst>
       <p:ext uri="{BB962C8B-B14F-4D97-AF65-F5344CB8AC3E}">
-        <p14:creationId xmlns:p14="http://schemas.microsoft.com/office/powerpoint/2010/main" val="3951853220"/>
+        <p14:creationId xmlns:p14="http://schemas.microsoft.com/office/powerpoint/2010/main" val="1587809001"/>
       </p:ext>
     </p:extLst>
   </p:cSld>
@@ -2494,7 +2494,7 @@
           <p:cNvPr id="2" name="Title 1">
             <a:extLst>
               <a:ext uri="{FF2B5EF4-FFF2-40B4-BE49-F238E27FC236}">
-                <a16:creationId xmlns:a16="http://schemas.microsoft.com/office/drawing/2014/main" id="{ED98F3F8-B5B1-349B-D240-D083BEDC37F9}"/>
+                <a16:creationId xmlns:a16="http://schemas.microsoft.com/office/drawing/2014/main" id="{24EE8DE4-48CB-6A9D-3FF0-9027EBD0AF93}"/>
               </a:ext>
             </a:extLst>
           </p:cNvPr>
@@ -2532,7 +2532,7 @@
           <p:cNvPr id="3" name="Picture Placeholder 2">
             <a:extLst>
               <a:ext uri="{FF2B5EF4-FFF2-40B4-BE49-F238E27FC236}">
-                <a16:creationId xmlns:a16="http://schemas.microsoft.com/office/drawing/2014/main" id="{D3D42F45-2FE5-19AB-0C03-7F918FE0F182}"/>
+                <a16:creationId xmlns:a16="http://schemas.microsoft.com/office/drawing/2014/main" id="{46ECD5C2-32D9-C1CB-2407-0ABAF3EC1FBC}"/>
               </a:ext>
             </a:extLst>
           </p:cNvPr>
@@ -2599,7 +2599,7 @@
           <p:cNvPr id="4" name="Text Placeholder 3">
             <a:extLst>
               <a:ext uri="{FF2B5EF4-FFF2-40B4-BE49-F238E27FC236}">
-                <a16:creationId xmlns:a16="http://schemas.microsoft.com/office/drawing/2014/main" id="{6993D21A-D8BE-684E-4A88-822F5868F633}"/>
+                <a16:creationId xmlns:a16="http://schemas.microsoft.com/office/drawing/2014/main" id="{06C1F6DA-84E2-1458-388E-4AE24D3E44D7}"/>
               </a:ext>
             </a:extLst>
           </p:cNvPr>
@@ -2670,7 +2670,7 @@
           <p:cNvPr id="5" name="Date Placeholder 4">
             <a:extLst>
               <a:ext uri="{FF2B5EF4-FFF2-40B4-BE49-F238E27FC236}">
-                <a16:creationId xmlns:a16="http://schemas.microsoft.com/office/drawing/2014/main" id="{149BF0FE-3706-E424-4090-B2E2C7D854E2}"/>
+                <a16:creationId xmlns:a16="http://schemas.microsoft.com/office/drawing/2014/main" id="{1D589658-EE11-6C7E-AFE2-82F00288CD89}"/>
               </a:ext>
             </a:extLst>
           </p:cNvPr>
@@ -2686,7 +2686,7 @@
           <a:bodyPr/>
           <a:lstStyle/>
           <a:p>
-            <a:fld id="{09A9739F-F1D6-4A09-9401-01D6C1617698}" type="datetimeFigureOut">
+            <a:fld id="{4416A6DF-60CD-44D2-B8D7-9C28A0EA7403}" type="datetimeFigureOut">
               <a:rPr lang="en-IN" smtClean="0"/>
               <a:t>16-09-2026</a:t>
             </a:fld>
@@ -2699,7 +2699,7 @@
           <p:cNvPr id="6" name="Footer Placeholder 5">
             <a:extLst>
               <a:ext uri="{FF2B5EF4-FFF2-40B4-BE49-F238E27FC236}">
-                <a16:creationId xmlns:a16="http://schemas.microsoft.com/office/drawing/2014/main" id="{3A57BA95-0E40-DA99-129F-D5DEBB5D60DA}"/>
+                <a16:creationId xmlns:a16="http://schemas.microsoft.com/office/drawing/2014/main" id="{162B9BD0-608F-5167-D880-8A5BCCABFDC8}"/>
               </a:ext>
             </a:extLst>
           </p:cNvPr>
@@ -2724,7 +2724,7 @@
           <p:cNvPr id="7" name="Slide Number Placeholder 6">
             <a:extLst>
               <a:ext uri="{FF2B5EF4-FFF2-40B4-BE49-F238E27FC236}">
-                <a16:creationId xmlns:a16="http://schemas.microsoft.com/office/drawing/2014/main" id="{09D0ADE7-BB0A-C9EE-512C-8162DD6125BC}"/>
+                <a16:creationId xmlns:a16="http://schemas.microsoft.com/office/drawing/2014/main" id="{3637D798-B5F6-F4ED-5396-FAD6F2D9FCB1}"/>
               </a:ext>
             </a:extLst>
           </p:cNvPr>
@@ -2740,7 +2740,7 @@
           <a:bodyPr/>
           <a:lstStyle/>
           <a:p>
-            <a:fld id="{D6C7D688-D6B0-499F-BF71-7CAA6C55BA1A}" type="slidenum">
+            <a:fld id="{78F6A441-4E7A-4D42-B657-3B8AA7E8D50A}" type="slidenum">
               <a:rPr lang="en-IN" smtClean="0"/>
               <a:t>‹#›</a:t>
             </a:fld>
@@ -2751,7 +2751,7 @@
     </p:spTree>
     <p:extLst>
       <p:ext uri="{BB962C8B-B14F-4D97-AF65-F5344CB8AC3E}">
-        <p14:creationId xmlns:p14="http://schemas.microsoft.com/office/powerpoint/2010/main" val="3238184270"/>
+        <p14:creationId xmlns:p14="http://schemas.microsoft.com/office/powerpoint/2010/main" val="3466140622"/>
       </p:ext>
     </p:extLst>
   </p:cSld>
@@ -2788,7 +2788,7 @@
           <p:cNvPr id="2" name="Title Placeholder 1">
             <a:extLst>
               <a:ext uri="{FF2B5EF4-FFF2-40B4-BE49-F238E27FC236}">
-                <a16:creationId xmlns:a16="http://schemas.microsoft.com/office/drawing/2014/main" id="{3C3688AE-9C1A-EEB3-9098-61CB3DD5F0B2}"/>
+                <a16:creationId xmlns:a16="http://schemas.microsoft.com/office/drawing/2014/main" id="{6DE09E23-C4DE-02B6-7DC0-FCE8DE345341}"/>
               </a:ext>
             </a:extLst>
           </p:cNvPr>
@@ -2827,7 +2827,7 @@
           <p:cNvPr id="3" name="Text Placeholder 2">
             <a:extLst>
               <a:ext uri="{FF2B5EF4-FFF2-40B4-BE49-F238E27FC236}">
-                <a16:creationId xmlns:a16="http://schemas.microsoft.com/office/drawing/2014/main" id="{8E9A013B-41B0-0A04-4E8B-6D8A1E390574}"/>
+                <a16:creationId xmlns:a16="http://schemas.microsoft.com/office/drawing/2014/main" id="{C64DAA44-1F8F-B60D-C99F-069AE9077437}"/>
               </a:ext>
             </a:extLst>
           </p:cNvPr>
@@ -2895,7 +2895,7 @@
           <p:cNvPr id="4" name="Date Placeholder 3">
             <a:extLst>
               <a:ext uri="{FF2B5EF4-FFF2-40B4-BE49-F238E27FC236}">
-                <a16:creationId xmlns:a16="http://schemas.microsoft.com/office/drawing/2014/main" id="{ACCED593-40F1-50E5-2F21-1F196269955A}"/>
+                <a16:creationId xmlns:a16="http://schemas.microsoft.com/office/drawing/2014/main" id="{79682D36-76C8-9BE7-FE5E-A536003CC644}"/>
               </a:ext>
             </a:extLst>
           </p:cNvPr>
@@ -2929,7 +2929,7 @@
             </a:lvl1pPr>
           </a:lstStyle>
           <a:p>
-            <a:fld id="{09A9739F-F1D6-4A09-9401-01D6C1617698}" type="datetimeFigureOut">
+            <a:fld id="{4416A6DF-60CD-44D2-B8D7-9C28A0EA7403}" type="datetimeFigureOut">
               <a:rPr lang="en-IN" smtClean="0"/>
               <a:t>16-09-2026</a:t>
             </a:fld>
@@ -2942,7 +2942,7 @@
           <p:cNvPr id="5" name="Footer Placeholder 4">
             <a:extLst>
               <a:ext uri="{FF2B5EF4-FFF2-40B4-BE49-F238E27FC236}">
-                <a16:creationId xmlns:a16="http://schemas.microsoft.com/office/drawing/2014/main" id="{F17DC588-C8CB-8A2C-D2B3-B5D1F948F84F}"/>
+                <a16:creationId xmlns:a16="http://schemas.microsoft.com/office/drawing/2014/main" id="{1469686D-D2FA-D47F-DCE8-810AB5D16BD3}"/>
               </a:ext>
             </a:extLst>
           </p:cNvPr>
@@ -2985,7 +2985,7 @@
           <p:cNvPr id="6" name="Slide Number Placeholder 5">
             <a:extLst>
               <a:ext uri="{FF2B5EF4-FFF2-40B4-BE49-F238E27FC236}">
-                <a16:creationId xmlns:a16="http://schemas.microsoft.com/office/drawing/2014/main" id="{B6FB4AC5-1274-02D3-E827-DFE3399D3ECB}"/>
+                <a16:creationId xmlns:a16="http://schemas.microsoft.com/office/drawing/2014/main" id="{05461102-2DE5-D0A4-1DB0-0C30F7E4C010}"/>
               </a:ext>
             </a:extLst>
           </p:cNvPr>
@@ -3019,7 +3019,7 @@
             </a:lvl1pPr>
           </a:lstStyle>
           <a:p>
-            <a:fld id="{D6C7D688-D6B0-499F-BF71-7CAA6C55BA1A}" type="slidenum">
+            <a:fld id="{78F6A441-4E7A-4D42-B657-3B8AA7E8D50A}" type="slidenum">
               <a:rPr lang="en-IN" smtClean="0"/>
               <a:t>‹#›</a:t>
             </a:fld>
@@ -3030,7 +3030,7 @@
     </p:spTree>
     <p:extLst>
       <p:ext uri="{BB962C8B-B14F-4D97-AF65-F5344CB8AC3E}">
-        <p14:creationId xmlns:p14="http://schemas.microsoft.com/office/powerpoint/2010/main" val="3277843122"/>
+        <p14:creationId xmlns:p14="http://schemas.microsoft.com/office/powerpoint/2010/main" val="3578614951"/>
       </p:ext>
     </p:extLst>
   </p:cSld>
@@ -3353,7 +3353,7 @@
           <p:cNvPr id="3" name="Picture 2">
             <a:extLst>
               <a:ext uri="{FF2B5EF4-FFF2-40B4-BE49-F238E27FC236}">
-                <a16:creationId xmlns:a16="http://schemas.microsoft.com/office/drawing/2014/main" id="{2E1FDF3C-063D-6FBE-099B-0850AD01CA29}"/>
+                <a16:creationId xmlns:a16="http://schemas.microsoft.com/office/drawing/2014/main" id="{0C8F65CA-7B50-75B5-33DE-6331082CB952}"/>
               </a:ext>
             </a:extLst>
           </p:cNvPr>
@@ -3387,7 +3387,7 @@
     </p:spTree>
     <p:extLst>
       <p:ext uri="{BB962C8B-B14F-4D97-AF65-F5344CB8AC3E}">
-        <p14:creationId xmlns:p14="http://schemas.microsoft.com/office/powerpoint/2010/main" val="2476326256"/>
+        <p14:creationId xmlns:p14="http://schemas.microsoft.com/office/powerpoint/2010/main" val="4167863200"/>
       </p:ext>
     </p:extLst>
   </p:cSld>
@@ -3419,7 +3419,7 @@
           <p:cNvPr id="3" name="Picture 2">
             <a:extLst>
               <a:ext uri="{FF2B5EF4-FFF2-40B4-BE49-F238E27FC236}">
-                <a16:creationId xmlns:a16="http://schemas.microsoft.com/office/drawing/2014/main" id="{FD94D03E-09E1-1302-4B9F-943DE3EFEBC8}"/>
+                <a16:creationId xmlns:a16="http://schemas.microsoft.com/office/drawing/2014/main" id="{0E712F35-D6B5-6358-8094-0AAFEDE49741}"/>
               </a:ext>
             </a:extLst>
           </p:cNvPr>
@@ -3453,7 +3453,7 @@
     </p:spTree>
     <p:extLst>
       <p:ext uri="{BB962C8B-B14F-4D97-AF65-F5344CB8AC3E}">
-        <p14:creationId xmlns:p14="http://schemas.microsoft.com/office/powerpoint/2010/main" val="1805237889"/>
+        <p14:creationId xmlns:p14="http://schemas.microsoft.com/office/powerpoint/2010/main" val="1166543672"/>
       </p:ext>
     </p:extLst>
   </p:cSld>
@@ -3485,7 +3485,7 @@
           <p:cNvPr id="3" name="Picture 2">
             <a:extLst>
               <a:ext uri="{FF2B5EF4-FFF2-40B4-BE49-F238E27FC236}">
-                <a16:creationId xmlns:a16="http://schemas.microsoft.com/office/drawing/2014/main" id="{12CCAB99-B824-62A9-CF76-7E938A491A4A}"/>
+                <a16:creationId xmlns:a16="http://schemas.microsoft.com/office/drawing/2014/main" id="{EBB20AFD-824E-CFC5-2218-38BBF3ED110F}"/>
               </a:ext>
             </a:extLst>
           </p:cNvPr>
@@ -3519,7 +3519,7 @@
     </p:spTree>
     <p:extLst>
       <p:ext uri="{BB962C8B-B14F-4D97-AF65-F5344CB8AC3E}">
-        <p14:creationId xmlns:p14="http://schemas.microsoft.com/office/powerpoint/2010/main" val="1060623749"/>
+        <p14:creationId xmlns:p14="http://schemas.microsoft.com/office/powerpoint/2010/main" val="220341424"/>
       </p:ext>
     </p:extLst>
   </p:cSld>
@@ -3551,7 +3551,7 @@
           <p:cNvPr id="3" name="Picture 2">
             <a:extLst>
               <a:ext uri="{FF2B5EF4-FFF2-40B4-BE49-F238E27FC236}">
-                <a16:creationId xmlns:a16="http://schemas.microsoft.com/office/drawing/2014/main" id="{05BB6061-F6B5-B101-E1B2-BB19C1341AB9}"/>
+                <a16:creationId xmlns:a16="http://schemas.microsoft.com/office/drawing/2014/main" id="{3522E53E-EB52-7B4A-CFEC-552FB0F170DB}"/>
               </a:ext>
             </a:extLst>
           </p:cNvPr>
@@ -3585,7 +3585,7 @@
     </p:spTree>
     <p:extLst>
       <p:ext uri="{BB962C8B-B14F-4D97-AF65-F5344CB8AC3E}">
-        <p14:creationId xmlns:p14="http://schemas.microsoft.com/office/powerpoint/2010/main" val="1008688601"/>
+        <p14:creationId xmlns:p14="http://schemas.microsoft.com/office/powerpoint/2010/main" val="3827210496"/>
       </p:ext>
     </p:extLst>
   </p:cSld>
@@ -3617,7 +3617,7 @@
           <p:cNvPr id="3" name="Picture 2">
             <a:extLst>
               <a:ext uri="{FF2B5EF4-FFF2-40B4-BE49-F238E27FC236}">
-                <a16:creationId xmlns:a16="http://schemas.microsoft.com/office/drawing/2014/main" id="{04727D11-454B-3F34-0F06-F848B727E643}"/>
+                <a16:creationId xmlns:a16="http://schemas.microsoft.com/office/drawing/2014/main" id="{91A72D1C-330F-B71C-DBA5-C4D6661F00C1}"/>
               </a:ext>
             </a:extLst>
           </p:cNvPr>
@@ -3651,7 +3651,7 @@
     </p:spTree>
     <p:extLst>
       <p:ext uri="{BB962C8B-B14F-4D97-AF65-F5344CB8AC3E}">
-        <p14:creationId xmlns:p14="http://schemas.microsoft.com/office/powerpoint/2010/main" val="2312997515"/>
+        <p14:creationId xmlns:p14="http://schemas.microsoft.com/office/powerpoint/2010/main" val="3730516436"/>
       </p:ext>
     </p:extLst>
   </p:cSld>
@@ -3683,7 +3683,7 @@
           <p:cNvPr id="3" name="Picture 2">
             <a:extLst>
               <a:ext uri="{FF2B5EF4-FFF2-40B4-BE49-F238E27FC236}">
-                <a16:creationId xmlns:a16="http://schemas.microsoft.com/office/drawing/2014/main" id="{D5977456-81BE-C608-96CD-6A112DD2FB21}"/>
+                <a16:creationId xmlns:a16="http://schemas.microsoft.com/office/drawing/2014/main" id="{F0B2C4A0-E7E1-EC78-9B1D-C3353D66AA5D}"/>
               </a:ext>
             </a:extLst>
           </p:cNvPr>
@@ -3717,7 +3717,7 @@
     </p:spTree>
     <p:extLst>
       <p:ext uri="{BB962C8B-B14F-4D97-AF65-F5344CB8AC3E}">
-        <p14:creationId xmlns:p14="http://schemas.microsoft.com/office/powerpoint/2010/main" val="2017557820"/>
+        <p14:creationId xmlns:p14="http://schemas.microsoft.com/office/powerpoint/2010/main" val="1024158855"/>
       </p:ext>
     </p:extLst>
   </p:cSld>
@@ -3749,7 +3749,7 @@
           <p:cNvPr id="3" name="Picture 2">
             <a:extLst>
               <a:ext uri="{FF2B5EF4-FFF2-40B4-BE49-F238E27FC236}">
-                <a16:creationId xmlns:a16="http://schemas.microsoft.com/office/drawing/2014/main" id="{0802EE7C-B286-F62B-C5D5-BAF9BD431EA9}"/>
+                <a16:creationId xmlns:a16="http://schemas.microsoft.com/office/drawing/2014/main" id="{3D1D22A7-E9B4-B080-C3B2-AF68ECC1DA93}"/>
               </a:ext>
             </a:extLst>
           </p:cNvPr>
@@ -3783,7 +3783,7 @@
     </p:spTree>
     <p:extLst>
       <p:ext uri="{BB962C8B-B14F-4D97-AF65-F5344CB8AC3E}">
-        <p14:creationId xmlns:p14="http://schemas.microsoft.com/office/powerpoint/2010/main" val="468748032"/>
+        <p14:creationId xmlns:p14="http://schemas.microsoft.com/office/powerpoint/2010/main" val="329975941"/>
       </p:ext>
     </p:extLst>
   </p:cSld>

</xml_diff>

<commit_message>
Unified single-theme high-detail deck: Qora_Pitch_Deck.pptx
</commit_message>
<xml_diff>
--- a/Qora_Pitch_Deck.pptx
+++ b/Qora_Pitch_Deck.pptx
@@ -135,7 +135,7 @@
           <p:cNvPr id="2" name="Title 1">
             <a:extLst>
               <a:ext uri="{FF2B5EF4-FFF2-40B4-BE49-F238E27FC236}">
-                <a16:creationId xmlns:a16="http://schemas.microsoft.com/office/drawing/2014/main" id="{AE331D86-BE25-CEFB-2A03-2CA6321AD496}"/>
+                <a16:creationId xmlns:a16="http://schemas.microsoft.com/office/drawing/2014/main" id="{8A07397A-1ACA-6699-5B0C-3DE97C57FB77}"/>
               </a:ext>
             </a:extLst>
           </p:cNvPr>
@@ -173,7 +173,7 @@
           <p:cNvPr id="3" name="Subtitle 2">
             <a:extLst>
               <a:ext uri="{FF2B5EF4-FFF2-40B4-BE49-F238E27FC236}">
-                <a16:creationId xmlns:a16="http://schemas.microsoft.com/office/drawing/2014/main" id="{22E193D9-CE02-C261-A954-06D96BB387E5}"/>
+                <a16:creationId xmlns:a16="http://schemas.microsoft.com/office/drawing/2014/main" id="{912B7E7D-CDD1-3209-31BA-BDBC32D6CAE9}"/>
               </a:ext>
             </a:extLst>
           </p:cNvPr>
@@ -244,7 +244,7 @@
           <p:cNvPr id="4" name="Date Placeholder 3">
             <a:extLst>
               <a:ext uri="{FF2B5EF4-FFF2-40B4-BE49-F238E27FC236}">
-                <a16:creationId xmlns:a16="http://schemas.microsoft.com/office/drawing/2014/main" id="{186ED22B-EDA7-A7A6-CA99-D5D1FEA3F7B7}"/>
+                <a16:creationId xmlns:a16="http://schemas.microsoft.com/office/drawing/2014/main" id="{EA696575-4838-66A4-716C-7A3DBE801E2A}"/>
               </a:ext>
             </a:extLst>
           </p:cNvPr>
@@ -260,7 +260,7 @@
           <a:bodyPr/>
           <a:lstStyle/>
           <a:p>
-            <a:fld id="{4416A6DF-60CD-44D2-B8D7-9C28A0EA7403}" type="datetimeFigureOut">
+            <a:fld id="{B343152C-D453-4594-B49F-69867965F11A}" type="datetimeFigureOut">
               <a:rPr lang="en-IN" smtClean="0"/>
               <a:t>16-09-2026</a:t>
             </a:fld>
@@ -273,7 +273,7 @@
           <p:cNvPr id="5" name="Footer Placeholder 4">
             <a:extLst>
               <a:ext uri="{FF2B5EF4-FFF2-40B4-BE49-F238E27FC236}">
-                <a16:creationId xmlns:a16="http://schemas.microsoft.com/office/drawing/2014/main" id="{5D9E8D64-DB25-FF57-BA1C-6EF7E4C3A5E8}"/>
+                <a16:creationId xmlns:a16="http://schemas.microsoft.com/office/drawing/2014/main" id="{F27B97C6-7E24-FBA7-775B-3B7E1B2AA106}"/>
               </a:ext>
             </a:extLst>
           </p:cNvPr>
@@ -298,7 +298,7 @@
           <p:cNvPr id="6" name="Slide Number Placeholder 5">
             <a:extLst>
               <a:ext uri="{FF2B5EF4-FFF2-40B4-BE49-F238E27FC236}">
-                <a16:creationId xmlns:a16="http://schemas.microsoft.com/office/drawing/2014/main" id="{CC658806-FB8A-CF95-22F6-AC0E91FBFF88}"/>
+                <a16:creationId xmlns:a16="http://schemas.microsoft.com/office/drawing/2014/main" id="{8B2F7F6D-093C-8C6B-D74C-BF5F95622DCF}"/>
               </a:ext>
             </a:extLst>
           </p:cNvPr>
@@ -314,7 +314,7 @@
           <a:bodyPr/>
           <a:lstStyle/>
           <a:p>
-            <a:fld id="{78F6A441-4E7A-4D42-B657-3B8AA7E8D50A}" type="slidenum">
+            <a:fld id="{3AB31993-B234-4B1C-A01D-03AA2FEA6D33}" type="slidenum">
               <a:rPr lang="en-IN" smtClean="0"/>
               <a:t>‹#›</a:t>
             </a:fld>
@@ -325,7 +325,7 @@
     </p:spTree>
     <p:extLst>
       <p:ext uri="{BB962C8B-B14F-4D97-AF65-F5344CB8AC3E}">
-        <p14:creationId xmlns:p14="http://schemas.microsoft.com/office/powerpoint/2010/main" val="1643598285"/>
+        <p14:creationId xmlns:p14="http://schemas.microsoft.com/office/powerpoint/2010/main" val="940292222"/>
       </p:ext>
     </p:extLst>
   </p:cSld>
@@ -357,7 +357,7 @@
           <p:cNvPr id="2" name="Title 1">
             <a:extLst>
               <a:ext uri="{FF2B5EF4-FFF2-40B4-BE49-F238E27FC236}">
-                <a16:creationId xmlns:a16="http://schemas.microsoft.com/office/drawing/2014/main" id="{FA01FB6F-F1CB-D9AB-5D74-8681FD761004}"/>
+                <a16:creationId xmlns:a16="http://schemas.microsoft.com/office/drawing/2014/main" id="{441A6224-1606-3F8C-B8E6-B2757E3B1FEF}"/>
               </a:ext>
             </a:extLst>
           </p:cNvPr>
@@ -386,7 +386,7 @@
           <p:cNvPr id="3" name="Vertical Text Placeholder 2">
             <a:extLst>
               <a:ext uri="{FF2B5EF4-FFF2-40B4-BE49-F238E27FC236}">
-                <a16:creationId xmlns:a16="http://schemas.microsoft.com/office/drawing/2014/main" id="{A2E289CB-2965-EF55-AB41-C9E58CE26396}"/>
+                <a16:creationId xmlns:a16="http://schemas.microsoft.com/office/drawing/2014/main" id="{6290CEB8-E626-4780-36F0-0C6979C9CACA}"/>
               </a:ext>
             </a:extLst>
           </p:cNvPr>
@@ -444,7 +444,7 @@
           <p:cNvPr id="4" name="Date Placeholder 3">
             <a:extLst>
               <a:ext uri="{FF2B5EF4-FFF2-40B4-BE49-F238E27FC236}">
-                <a16:creationId xmlns:a16="http://schemas.microsoft.com/office/drawing/2014/main" id="{F78FCEF0-786F-96CC-EDF8-556340326A1F}"/>
+                <a16:creationId xmlns:a16="http://schemas.microsoft.com/office/drawing/2014/main" id="{174B9141-A150-8421-FAF6-502A21589AB8}"/>
               </a:ext>
             </a:extLst>
           </p:cNvPr>
@@ -460,7 +460,7 @@
           <a:bodyPr/>
           <a:lstStyle/>
           <a:p>
-            <a:fld id="{4416A6DF-60CD-44D2-B8D7-9C28A0EA7403}" type="datetimeFigureOut">
+            <a:fld id="{B343152C-D453-4594-B49F-69867965F11A}" type="datetimeFigureOut">
               <a:rPr lang="en-IN" smtClean="0"/>
               <a:t>16-09-2026</a:t>
             </a:fld>
@@ -473,7 +473,7 @@
           <p:cNvPr id="5" name="Footer Placeholder 4">
             <a:extLst>
               <a:ext uri="{FF2B5EF4-FFF2-40B4-BE49-F238E27FC236}">
-                <a16:creationId xmlns:a16="http://schemas.microsoft.com/office/drawing/2014/main" id="{1FF78BD0-B91F-290E-BCE5-A32FB257645A}"/>
+                <a16:creationId xmlns:a16="http://schemas.microsoft.com/office/drawing/2014/main" id="{1E964F1A-4774-F455-2553-20FAE31AA8C0}"/>
               </a:ext>
             </a:extLst>
           </p:cNvPr>
@@ -498,7 +498,7 @@
           <p:cNvPr id="6" name="Slide Number Placeholder 5">
             <a:extLst>
               <a:ext uri="{FF2B5EF4-FFF2-40B4-BE49-F238E27FC236}">
-                <a16:creationId xmlns:a16="http://schemas.microsoft.com/office/drawing/2014/main" id="{2CEC11E7-9990-75C7-98E8-62A47586C0A0}"/>
+                <a16:creationId xmlns:a16="http://schemas.microsoft.com/office/drawing/2014/main" id="{4F9FBE82-B631-5703-0DA2-9E8409225E7A}"/>
               </a:ext>
             </a:extLst>
           </p:cNvPr>
@@ -514,7 +514,7 @@
           <a:bodyPr/>
           <a:lstStyle/>
           <a:p>
-            <a:fld id="{78F6A441-4E7A-4D42-B657-3B8AA7E8D50A}" type="slidenum">
+            <a:fld id="{3AB31993-B234-4B1C-A01D-03AA2FEA6D33}" type="slidenum">
               <a:rPr lang="en-IN" smtClean="0"/>
               <a:t>‹#›</a:t>
             </a:fld>
@@ -525,7 +525,7 @@
     </p:spTree>
     <p:extLst>
       <p:ext uri="{BB962C8B-B14F-4D97-AF65-F5344CB8AC3E}">
-        <p14:creationId xmlns:p14="http://schemas.microsoft.com/office/powerpoint/2010/main" val="961528872"/>
+        <p14:creationId xmlns:p14="http://schemas.microsoft.com/office/powerpoint/2010/main" val="3362182826"/>
       </p:ext>
     </p:extLst>
   </p:cSld>
@@ -557,7 +557,7 @@
           <p:cNvPr id="2" name="Vertical Title 1">
             <a:extLst>
               <a:ext uri="{FF2B5EF4-FFF2-40B4-BE49-F238E27FC236}">
-                <a16:creationId xmlns:a16="http://schemas.microsoft.com/office/drawing/2014/main" id="{3BC2054F-B881-8A86-1367-D50DBD0EA331}"/>
+                <a16:creationId xmlns:a16="http://schemas.microsoft.com/office/drawing/2014/main" id="{4CADAD8B-F18D-ACB1-25D3-DC411341AFCC}"/>
               </a:ext>
             </a:extLst>
           </p:cNvPr>
@@ -591,7 +591,7 @@
           <p:cNvPr id="3" name="Vertical Text Placeholder 2">
             <a:extLst>
               <a:ext uri="{FF2B5EF4-FFF2-40B4-BE49-F238E27FC236}">
-                <a16:creationId xmlns:a16="http://schemas.microsoft.com/office/drawing/2014/main" id="{D8647D9B-F212-C98B-9033-73D8C9F08D22}"/>
+                <a16:creationId xmlns:a16="http://schemas.microsoft.com/office/drawing/2014/main" id="{24E4F984-575C-F19F-49CF-6FC09E811EDD}"/>
               </a:ext>
             </a:extLst>
           </p:cNvPr>
@@ -654,7 +654,7 @@
           <p:cNvPr id="4" name="Date Placeholder 3">
             <a:extLst>
               <a:ext uri="{FF2B5EF4-FFF2-40B4-BE49-F238E27FC236}">
-                <a16:creationId xmlns:a16="http://schemas.microsoft.com/office/drawing/2014/main" id="{72136AB0-959B-33F7-1477-B8EB0FFB0E0A}"/>
+                <a16:creationId xmlns:a16="http://schemas.microsoft.com/office/drawing/2014/main" id="{D8056815-B0AA-5B33-188E-0630AFAD59F2}"/>
               </a:ext>
             </a:extLst>
           </p:cNvPr>
@@ -670,7 +670,7 @@
           <a:bodyPr/>
           <a:lstStyle/>
           <a:p>
-            <a:fld id="{4416A6DF-60CD-44D2-B8D7-9C28A0EA7403}" type="datetimeFigureOut">
+            <a:fld id="{B343152C-D453-4594-B49F-69867965F11A}" type="datetimeFigureOut">
               <a:rPr lang="en-IN" smtClean="0"/>
               <a:t>16-09-2026</a:t>
             </a:fld>
@@ -683,7 +683,7 @@
           <p:cNvPr id="5" name="Footer Placeholder 4">
             <a:extLst>
               <a:ext uri="{FF2B5EF4-FFF2-40B4-BE49-F238E27FC236}">
-                <a16:creationId xmlns:a16="http://schemas.microsoft.com/office/drawing/2014/main" id="{87461387-2D89-E265-C28A-C0040E6D43EC}"/>
+                <a16:creationId xmlns:a16="http://schemas.microsoft.com/office/drawing/2014/main" id="{EFCAAF3F-927F-0DAA-37F3-C3DD86891AA4}"/>
               </a:ext>
             </a:extLst>
           </p:cNvPr>
@@ -708,7 +708,7 @@
           <p:cNvPr id="6" name="Slide Number Placeholder 5">
             <a:extLst>
               <a:ext uri="{FF2B5EF4-FFF2-40B4-BE49-F238E27FC236}">
-                <a16:creationId xmlns:a16="http://schemas.microsoft.com/office/drawing/2014/main" id="{149C5776-DB88-6D96-566E-9B6D61455FE8}"/>
+                <a16:creationId xmlns:a16="http://schemas.microsoft.com/office/drawing/2014/main" id="{92C91B01-37B8-78E2-EB05-DE05DCEC15EA}"/>
               </a:ext>
             </a:extLst>
           </p:cNvPr>
@@ -724,7 +724,7 @@
           <a:bodyPr/>
           <a:lstStyle/>
           <a:p>
-            <a:fld id="{78F6A441-4E7A-4D42-B657-3B8AA7E8D50A}" type="slidenum">
+            <a:fld id="{3AB31993-B234-4B1C-A01D-03AA2FEA6D33}" type="slidenum">
               <a:rPr lang="en-IN" smtClean="0"/>
               <a:t>‹#›</a:t>
             </a:fld>
@@ -735,7 +735,7 @@
     </p:spTree>
     <p:extLst>
       <p:ext uri="{BB962C8B-B14F-4D97-AF65-F5344CB8AC3E}">
-        <p14:creationId xmlns:p14="http://schemas.microsoft.com/office/powerpoint/2010/main" val="174007801"/>
+        <p14:creationId xmlns:p14="http://schemas.microsoft.com/office/powerpoint/2010/main" val="1049220253"/>
       </p:ext>
     </p:extLst>
   </p:cSld>
@@ -767,7 +767,7 @@
           <p:cNvPr id="2" name="Title 1">
             <a:extLst>
               <a:ext uri="{FF2B5EF4-FFF2-40B4-BE49-F238E27FC236}">
-                <a16:creationId xmlns:a16="http://schemas.microsoft.com/office/drawing/2014/main" id="{3F978C4C-7451-41E8-A8BC-2659A37C60F9}"/>
+                <a16:creationId xmlns:a16="http://schemas.microsoft.com/office/drawing/2014/main" id="{6ECE988A-4498-EC6E-8382-6F2CDDFE2F39}"/>
               </a:ext>
             </a:extLst>
           </p:cNvPr>
@@ -796,7 +796,7 @@
           <p:cNvPr id="3" name="Content Placeholder 2">
             <a:extLst>
               <a:ext uri="{FF2B5EF4-FFF2-40B4-BE49-F238E27FC236}">
-                <a16:creationId xmlns:a16="http://schemas.microsoft.com/office/drawing/2014/main" id="{0806F02E-5866-AAD9-883F-B73E93F7F987}"/>
+                <a16:creationId xmlns:a16="http://schemas.microsoft.com/office/drawing/2014/main" id="{4BCEABEA-6D54-C43A-069D-A2BE92618097}"/>
               </a:ext>
             </a:extLst>
           </p:cNvPr>
@@ -854,7 +854,7 @@
           <p:cNvPr id="4" name="Date Placeholder 3">
             <a:extLst>
               <a:ext uri="{FF2B5EF4-FFF2-40B4-BE49-F238E27FC236}">
-                <a16:creationId xmlns:a16="http://schemas.microsoft.com/office/drawing/2014/main" id="{6788B479-1D98-ABEA-243D-CFE841786C23}"/>
+                <a16:creationId xmlns:a16="http://schemas.microsoft.com/office/drawing/2014/main" id="{F589899B-7392-B362-8236-844582DDD7B1}"/>
               </a:ext>
             </a:extLst>
           </p:cNvPr>
@@ -870,7 +870,7 @@
           <a:bodyPr/>
           <a:lstStyle/>
           <a:p>
-            <a:fld id="{4416A6DF-60CD-44D2-B8D7-9C28A0EA7403}" type="datetimeFigureOut">
+            <a:fld id="{B343152C-D453-4594-B49F-69867965F11A}" type="datetimeFigureOut">
               <a:rPr lang="en-IN" smtClean="0"/>
               <a:t>16-09-2026</a:t>
             </a:fld>
@@ -883,7 +883,7 @@
           <p:cNvPr id="5" name="Footer Placeholder 4">
             <a:extLst>
               <a:ext uri="{FF2B5EF4-FFF2-40B4-BE49-F238E27FC236}">
-                <a16:creationId xmlns:a16="http://schemas.microsoft.com/office/drawing/2014/main" id="{19F78120-9BDB-4755-68D2-B21D9C704637}"/>
+                <a16:creationId xmlns:a16="http://schemas.microsoft.com/office/drawing/2014/main" id="{B6F79FC7-D92A-02F8-1DDC-E5B8A6474C5A}"/>
               </a:ext>
             </a:extLst>
           </p:cNvPr>
@@ -908,7 +908,7 @@
           <p:cNvPr id="6" name="Slide Number Placeholder 5">
             <a:extLst>
               <a:ext uri="{FF2B5EF4-FFF2-40B4-BE49-F238E27FC236}">
-                <a16:creationId xmlns:a16="http://schemas.microsoft.com/office/drawing/2014/main" id="{58C8D5E6-31D2-ACB8-E91B-B1A45789A366}"/>
+                <a16:creationId xmlns:a16="http://schemas.microsoft.com/office/drawing/2014/main" id="{268AA3CF-1D5A-69AF-53FA-BDF2E99A467C}"/>
               </a:ext>
             </a:extLst>
           </p:cNvPr>
@@ -924,7 +924,7 @@
           <a:bodyPr/>
           <a:lstStyle/>
           <a:p>
-            <a:fld id="{78F6A441-4E7A-4D42-B657-3B8AA7E8D50A}" type="slidenum">
+            <a:fld id="{3AB31993-B234-4B1C-A01D-03AA2FEA6D33}" type="slidenum">
               <a:rPr lang="en-IN" smtClean="0"/>
               <a:t>‹#›</a:t>
             </a:fld>
@@ -935,7 +935,7 @@
     </p:spTree>
     <p:extLst>
       <p:ext uri="{BB962C8B-B14F-4D97-AF65-F5344CB8AC3E}">
-        <p14:creationId xmlns:p14="http://schemas.microsoft.com/office/powerpoint/2010/main" val="3466748157"/>
+        <p14:creationId xmlns:p14="http://schemas.microsoft.com/office/powerpoint/2010/main" val="296650474"/>
       </p:ext>
     </p:extLst>
   </p:cSld>
@@ -967,7 +967,7 @@
           <p:cNvPr id="2" name="Title 1">
             <a:extLst>
               <a:ext uri="{FF2B5EF4-FFF2-40B4-BE49-F238E27FC236}">
-                <a16:creationId xmlns:a16="http://schemas.microsoft.com/office/drawing/2014/main" id="{2A69ED34-5058-B332-106A-B633A9FC9D5B}"/>
+                <a16:creationId xmlns:a16="http://schemas.microsoft.com/office/drawing/2014/main" id="{2D0848EB-3C19-BC88-F61E-4D70B2C194DD}"/>
               </a:ext>
             </a:extLst>
           </p:cNvPr>
@@ -1005,7 +1005,7 @@
           <p:cNvPr id="3" name="Text Placeholder 2">
             <a:extLst>
               <a:ext uri="{FF2B5EF4-FFF2-40B4-BE49-F238E27FC236}">
-                <a16:creationId xmlns:a16="http://schemas.microsoft.com/office/drawing/2014/main" id="{0D6C8C4C-43EC-3A6E-D443-48F85DEEBD73}"/>
+                <a16:creationId xmlns:a16="http://schemas.microsoft.com/office/drawing/2014/main" id="{38716EFB-A32A-64CB-819A-981B4B849C24}"/>
               </a:ext>
             </a:extLst>
           </p:cNvPr>
@@ -1130,7 +1130,7 @@
           <p:cNvPr id="4" name="Date Placeholder 3">
             <a:extLst>
               <a:ext uri="{FF2B5EF4-FFF2-40B4-BE49-F238E27FC236}">
-                <a16:creationId xmlns:a16="http://schemas.microsoft.com/office/drawing/2014/main" id="{5E6E2461-39CF-C82C-76CE-06B68F2CD0C2}"/>
+                <a16:creationId xmlns:a16="http://schemas.microsoft.com/office/drawing/2014/main" id="{DDA5C46F-0FD5-F791-9DD1-11FE8FC84085}"/>
               </a:ext>
             </a:extLst>
           </p:cNvPr>
@@ -1146,7 +1146,7 @@
           <a:bodyPr/>
           <a:lstStyle/>
           <a:p>
-            <a:fld id="{4416A6DF-60CD-44D2-B8D7-9C28A0EA7403}" type="datetimeFigureOut">
+            <a:fld id="{B343152C-D453-4594-B49F-69867965F11A}" type="datetimeFigureOut">
               <a:rPr lang="en-IN" smtClean="0"/>
               <a:t>16-09-2026</a:t>
             </a:fld>
@@ -1159,7 +1159,7 @@
           <p:cNvPr id="5" name="Footer Placeholder 4">
             <a:extLst>
               <a:ext uri="{FF2B5EF4-FFF2-40B4-BE49-F238E27FC236}">
-                <a16:creationId xmlns:a16="http://schemas.microsoft.com/office/drawing/2014/main" id="{D31A7BEC-57C7-4AD4-2730-7A163AA5B8F6}"/>
+                <a16:creationId xmlns:a16="http://schemas.microsoft.com/office/drawing/2014/main" id="{0CE82B62-841B-1554-86F0-A193A79D5782}"/>
               </a:ext>
             </a:extLst>
           </p:cNvPr>
@@ -1184,7 +1184,7 @@
           <p:cNvPr id="6" name="Slide Number Placeholder 5">
             <a:extLst>
               <a:ext uri="{FF2B5EF4-FFF2-40B4-BE49-F238E27FC236}">
-                <a16:creationId xmlns:a16="http://schemas.microsoft.com/office/drawing/2014/main" id="{C8B184E9-B4BD-142E-CA77-FC69AD82C87B}"/>
+                <a16:creationId xmlns:a16="http://schemas.microsoft.com/office/drawing/2014/main" id="{241BFF2C-9CFA-BA5D-350C-068BBDA6F1C5}"/>
               </a:ext>
             </a:extLst>
           </p:cNvPr>
@@ -1200,7 +1200,7 @@
           <a:bodyPr/>
           <a:lstStyle/>
           <a:p>
-            <a:fld id="{78F6A441-4E7A-4D42-B657-3B8AA7E8D50A}" type="slidenum">
+            <a:fld id="{3AB31993-B234-4B1C-A01D-03AA2FEA6D33}" type="slidenum">
               <a:rPr lang="en-IN" smtClean="0"/>
               <a:t>‹#›</a:t>
             </a:fld>
@@ -1211,7 +1211,7 @@
     </p:spTree>
     <p:extLst>
       <p:ext uri="{BB962C8B-B14F-4D97-AF65-F5344CB8AC3E}">
-        <p14:creationId xmlns:p14="http://schemas.microsoft.com/office/powerpoint/2010/main" val="1182768736"/>
+        <p14:creationId xmlns:p14="http://schemas.microsoft.com/office/powerpoint/2010/main" val="1759768794"/>
       </p:ext>
     </p:extLst>
   </p:cSld>
@@ -1243,7 +1243,7 @@
           <p:cNvPr id="2" name="Title 1">
             <a:extLst>
               <a:ext uri="{FF2B5EF4-FFF2-40B4-BE49-F238E27FC236}">
-                <a16:creationId xmlns:a16="http://schemas.microsoft.com/office/drawing/2014/main" id="{B0B6619B-5EAC-BF6D-A52C-E8DA68018F7E}"/>
+                <a16:creationId xmlns:a16="http://schemas.microsoft.com/office/drawing/2014/main" id="{FF9D0EFD-8C52-7F97-3B00-E91061BE932C}"/>
               </a:ext>
             </a:extLst>
           </p:cNvPr>
@@ -1272,7 +1272,7 @@
           <p:cNvPr id="3" name="Content Placeholder 2">
             <a:extLst>
               <a:ext uri="{FF2B5EF4-FFF2-40B4-BE49-F238E27FC236}">
-                <a16:creationId xmlns:a16="http://schemas.microsoft.com/office/drawing/2014/main" id="{E35AE98C-B331-C543-0E5C-1CB9903EBFF4}"/>
+                <a16:creationId xmlns:a16="http://schemas.microsoft.com/office/drawing/2014/main" id="{FD82BDBC-3EED-6A6B-A23B-28AAF3693980}"/>
               </a:ext>
             </a:extLst>
           </p:cNvPr>
@@ -1335,7 +1335,7 @@
           <p:cNvPr id="4" name="Content Placeholder 3">
             <a:extLst>
               <a:ext uri="{FF2B5EF4-FFF2-40B4-BE49-F238E27FC236}">
-                <a16:creationId xmlns:a16="http://schemas.microsoft.com/office/drawing/2014/main" id="{AA3B9386-1F02-EA61-4B54-C19E834D98E1}"/>
+                <a16:creationId xmlns:a16="http://schemas.microsoft.com/office/drawing/2014/main" id="{DC49EFBF-965C-3534-1B51-A581DE1EF7C2}"/>
               </a:ext>
             </a:extLst>
           </p:cNvPr>
@@ -1398,7 +1398,7 @@
           <p:cNvPr id="5" name="Date Placeholder 4">
             <a:extLst>
               <a:ext uri="{FF2B5EF4-FFF2-40B4-BE49-F238E27FC236}">
-                <a16:creationId xmlns:a16="http://schemas.microsoft.com/office/drawing/2014/main" id="{E95BE431-29AF-8467-797E-1417E5E49109}"/>
+                <a16:creationId xmlns:a16="http://schemas.microsoft.com/office/drawing/2014/main" id="{846D7886-CAE0-0AE2-3500-164BA53AAF91}"/>
               </a:ext>
             </a:extLst>
           </p:cNvPr>
@@ -1414,7 +1414,7 @@
           <a:bodyPr/>
           <a:lstStyle/>
           <a:p>
-            <a:fld id="{4416A6DF-60CD-44D2-B8D7-9C28A0EA7403}" type="datetimeFigureOut">
+            <a:fld id="{B343152C-D453-4594-B49F-69867965F11A}" type="datetimeFigureOut">
               <a:rPr lang="en-IN" smtClean="0"/>
               <a:t>16-09-2026</a:t>
             </a:fld>
@@ -1427,7 +1427,7 @@
           <p:cNvPr id="6" name="Footer Placeholder 5">
             <a:extLst>
               <a:ext uri="{FF2B5EF4-FFF2-40B4-BE49-F238E27FC236}">
-                <a16:creationId xmlns:a16="http://schemas.microsoft.com/office/drawing/2014/main" id="{D7C7FCF6-7D1B-C18E-DD9D-6961EF65D45C}"/>
+                <a16:creationId xmlns:a16="http://schemas.microsoft.com/office/drawing/2014/main" id="{E6660F47-85B1-70DD-ACCE-ADE2040E3048}"/>
               </a:ext>
             </a:extLst>
           </p:cNvPr>
@@ -1452,7 +1452,7 @@
           <p:cNvPr id="7" name="Slide Number Placeholder 6">
             <a:extLst>
               <a:ext uri="{FF2B5EF4-FFF2-40B4-BE49-F238E27FC236}">
-                <a16:creationId xmlns:a16="http://schemas.microsoft.com/office/drawing/2014/main" id="{D23C411B-8031-A00E-EE3A-FA1B1AE98F87}"/>
+                <a16:creationId xmlns:a16="http://schemas.microsoft.com/office/drawing/2014/main" id="{3F9FF737-D8B6-6269-AD8C-57FDFD1618AD}"/>
               </a:ext>
             </a:extLst>
           </p:cNvPr>
@@ -1468,7 +1468,7 @@
           <a:bodyPr/>
           <a:lstStyle/>
           <a:p>
-            <a:fld id="{78F6A441-4E7A-4D42-B657-3B8AA7E8D50A}" type="slidenum">
+            <a:fld id="{3AB31993-B234-4B1C-A01D-03AA2FEA6D33}" type="slidenum">
               <a:rPr lang="en-IN" smtClean="0"/>
               <a:t>‹#›</a:t>
             </a:fld>
@@ -1479,7 +1479,7 @@
     </p:spTree>
     <p:extLst>
       <p:ext uri="{BB962C8B-B14F-4D97-AF65-F5344CB8AC3E}">
-        <p14:creationId xmlns:p14="http://schemas.microsoft.com/office/powerpoint/2010/main" val="2795033478"/>
+        <p14:creationId xmlns:p14="http://schemas.microsoft.com/office/powerpoint/2010/main" val="1773708843"/>
       </p:ext>
     </p:extLst>
   </p:cSld>
@@ -1511,7 +1511,7 @@
           <p:cNvPr id="2" name="Title 1">
             <a:extLst>
               <a:ext uri="{FF2B5EF4-FFF2-40B4-BE49-F238E27FC236}">
-                <a16:creationId xmlns:a16="http://schemas.microsoft.com/office/drawing/2014/main" id="{5B8912E4-3C88-A92A-4A02-99A84AC77CF9}"/>
+                <a16:creationId xmlns:a16="http://schemas.microsoft.com/office/drawing/2014/main" id="{9CCC58FB-B7FE-7D1C-ACB3-BD7A2612058B}"/>
               </a:ext>
             </a:extLst>
           </p:cNvPr>
@@ -1545,7 +1545,7 @@
           <p:cNvPr id="3" name="Text Placeholder 2">
             <a:extLst>
               <a:ext uri="{FF2B5EF4-FFF2-40B4-BE49-F238E27FC236}">
-                <a16:creationId xmlns:a16="http://schemas.microsoft.com/office/drawing/2014/main" id="{A749C749-D8DD-3259-42E5-5CDA14AE46A6}"/>
+                <a16:creationId xmlns:a16="http://schemas.microsoft.com/office/drawing/2014/main" id="{995AFBC8-9C15-D7D7-4DC2-6AD0A0AB76A8}"/>
               </a:ext>
             </a:extLst>
           </p:cNvPr>
@@ -1616,7 +1616,7 @@
           <p:cNvPr id="4" name="Content Placeholder 3">
             <a:extLst>
               <a:ext uri="{FF2B5EF4-FFF2-40B4-BE49-F238E27FC236}">
-                <a16:creationId xmlns:a16="http://schemas.microsoft.com/office/drawing/2014/main" id="{B0C16441-E601-803D-D94B-7E49F6A4830D}"/>
+                <a16:creationId xmlns:a16="http://schemas.microsoft.com/office/drawing/2014/main" id="{82DE49E5-0F3D-1BAF-1270-F074489A4E2F}"/>
               </a:ext>
             </a:extLst>
           </p:cNvPr>
@@ -1679,7 +1679,7 @@
           <p:cNvPr id="5" name="Text Placeholder 4">
             <a:extLst>
               <a:ext uri="{FF2B5EF4-FFF2-40B4-BE49-F238E27FC236}">
-                <a16:creationId xmlns:a16="http://schemas.microsoft.com/office/drawing/2014/main" id="{F560DE51-93D8-8022-2B9B-D1248EDE6EEC}"/>
+                <a16:creationId xmlns:a16="http://schemas.microsoft.com/office/drawing/2014/main" id="{8F9433AC-AAAC-321D-6FC9-2E8C9AE9F313}"/>
               </a:ext>
             </a:extLst>
           </p:cNvPr>
@@ -1750,7 +1750,7 @@
           <p:cNvPr id="6" name="Content Placeholder 5">
             <a:extLst>
               <a:ext uri="{FF2B5EF4-FFF2-40B4-BE49-F238E27FC236}">
-                <a16:creationId xmlns:a16="http://schemas.microsoft.com/office/drawing/2014/main" id="{96BE7716-E221-4881-A858-B3E6024BA2FF}"/>
+                <a16:creationId xmlns:a16="http://schemas.microsoft.com/office/drawing/2014/main" id="{20CBF5EC-27FF-9BBA-8658-D410EE3C03C9}"/>
               </a:ext>
             </a:extLst>
           </p:cNvPr>
@@ -1813,7 +1813,7 @@
           <p:cNvPr id="7" name="Date Placeholder 6">
             <a:extLst>
               <a:ext uri="{FF2B5EF4-FFF2-40B4-BE49-F238E27FC236}">
-                <a16:creationId xmlns:a16="http://schemas.microsoft.com/office/drawing/2014/main" id="{C976AB88-9FDE-B2DD-B292-900012710DCA}"/>
+                <a16:creationId xmlns:a16="http://schemas.microsoft.com/office/drawing/2014/main" id="{95FCF2BD-60A2-4729-DA88-3467D4D8438E}"/>
               </a:ext>
             </a:extLst>
           </p:cNvPr>
@@ -1829,7 +1829,7 @@
           <a:bodyPr/>
           <a:lstStyle/>
           <a:p>
-            <a:fld id="{4416A6DF-60CD-44D2-B8D7-9C28A0EA7403}" type="datetimeFigureOut">
+            <a:fld id="{B343152C-D453-4594-B49F-69867965F11A}" type="datetimeFigureOut">
               <a:rPr lang="en-IN" smtClean="0"/>
               <a:t>16-09-2026</a:t>
             </a:fld>
@@ -1842,7 +1842,7 @@
           <p:cNvPr id="8" name="Footer Placeholder 7">
             <a:extLst>
               <a:ext uri="{FF2B5EF4-FFF2-40B4-BE49-F238E27FC236}">
-                <a16:creationId xmlns:a16="http://schemas.microsoft.com/office/drawing/2014/main" id="{80CB0BBC-937D-F7C5-ED4B-A3870D059479}"/>
+                <a16:creationId xmlns:a16="http://schemas.microsoft.com/office/drawing/2014/main" id="{EE5A2B4E-E6D1-B92C-0D4A-C097C1FFCCB0}"/>
               </a:ext>
             </a:extLst>
           </p:cNvPr>
@@ -1867,7 +1867,7 @@
           <p:cNvPr id="9" name="Slide Number Placeholder 8">
             <a:extLst>
               <a:ext uri="{FF2B5EF4-FFF2-40B4-BE49-F238E27FC236}">
-                <a16:creationId xmlns:a16="http://schemas.microsoft.com/office/drawing/2014/main" id="{D89AD8C0-514C-FF42-6673-A9176C0FC910}"/>
+                <a16:creationId xmlns:a16="http://schemas.microsoft.com/office/drawing/2014/main" id="{E4729107-BF9D-8263-5E55-C6EF26941F8C}"/>
               </a:ext>
             </a:extLst>
           </p:cNvPr>
@@ -1883,7 +1883,7 @@
           <a:bodyPr/>
           <a:lstStyle/>
           <a:p>
-            <a:fld id="{78F6A441-4E7A-4D42-B657-3B8AA7E8D50A}" type="slidenum">
+            <a:fld id="{3AB31993-B234-4B1C-A01D-03AA2FEA6D33}" type="slidenum">
               <a:rPr lang="en-IN" smtClean="0"/>
               <a:t>‹#›</a:t>
             </a:fld>
@@ -1894,7 +1894,7 @@
     </p:spTree>
     <p:extLst>
       <p:ext uri="{BB962C8B-B14F-4D97-AF65-F5344CB8AC3E}">
-        <p14:creationId xmlns:p14="http://schemas.microsoft.com/office/powerpoint/2010/main" val="3002669140"/>
+        <p14:creationId xmlns:p14="http://schemas.microsoft.com/office/powerpoint/2010/main" val="1943797973"/>
       </p:ext>
     </p:extLst>
   </p:cSld>
@@ -1926,7 +1926,7 @@
           <p:cNvPr id="2" name="Title 1">
             <a:extLst>
               <a:ext uri="{FF2B5EF4-FFF2-40B4-BE49-F238E27FC236}">
-                <a16:creationId xmlns:a16="http://schemas.microsoft.com/office/drawing/2014/main" id="{DAED0D50-08D6-7F26-1E19-4CC8A2C126D4}"/>
+                <a16:creationId xmlns:a16="http://schemas.microsoft.com/office/drawing/2014/main" id="{DBF3C76A-B57C-A59D-3AF7-80894FBAC070}"/>
               </a:ext>
             </a:extLst>
           </p:cNvPr>
@@ -1955,7 +1955,7 @@
           <p:cNvPr id="3" name="Date Placeholder 2">
             <a:extLst>
               <a:ext uri="{FF2B5EF4-FFF2-40B4-BE49-F238E27FC236}">
-                <a16:creationId xmlns:a16="http://schemas.microsoft.com/office/drawing/2014/main" id="{2CFAF460-0D4C-0762-89D9-049905A1477A}"/>
+                <a16:creationId xmlns:a16="http://schemas.microsoft.com/office/drawing/2014/main" id="{80D69C09-59F8-D08A-5D09-C36041BC9F48}"/>
               </a:ext>
             </a:extLst>
           </p:cNvPr>
@@ -1971,7 +1971,7 @@
           <a:bodyPr/>
           <a:lstStyle/>
           <a:p>
-            <a:fld id="{4416A6DF-60CD-44D2-B8D7-9C28A0EA7403}" type="datetimeFigureOut">
+            <a:fld id="{B343152C-D453-4594-B49F-69867965F11A}" type="datetimeFigureOut">
               <a:rPr lang="en-IN" smtClean="0"/>
               <a:t>16-09-2026</a:t>
             </a:fld>
@@ -1984,7 +1984,7 @@
           <p:cNvPr id="4" name="Footer Placeholder 3">
             <a:extLst>
               <a:ext uri="{FF2B5EF4-FFF2-40B4-BE49-F238E27FC236}">
-                <a16:creationId xmlns:a16="http://schemas.microsoft.com/office/drawing/2014/main" id="{239286A0-5B83-BC5C-B893-1BA79B9F1E7D}"/>
+                <a16:creationId xmlns:a16="http://schemas.microsoft.com/office/drawing/2014/main" id="{0CAA3277-FBEB-3473-28D3-ED19D307D8CE}"/>
               </a:ext>
             </a:extLst>
           </p:cNvPr>
@@ -2009,7 +2009,7 @@
           <p:cNvPr id="5" name="Slide Number Placeholder 4">
             <a:extLst>
               <a:ext uri="{FF2B5EF4-FFF2-40B4-BE49-F238E27FC236}">
-                <a16:creationId xmlns:a16="http://schemas.microsoft.com/office/drawing/2014/main" id="{066F9CCE-77A5-5C46-6353-440A1D8E3A88}"/>
+                <a16:creationId xmlns:a16="http://schemas.microsoft.com/office/drawing/2014/main" id="{65B69C42-898D-52B9-3634-654AE686987B}"/>
               </a:ext>
             </a:extLst>
           </p:cNvPr>
@@ -2025,7 +2025,7 @@
           <a:bodyPr/>
           <a:lstStyle/>
           <a:p>
-            <a:fld id="{78F6A441-4E7A-4D42-B657-3B8AA7E8D50A}" type="slidenum">
+            <a:fld id="{3AB31993-B234-4B1C-A01D-03AA2FEA6D33}" type="slidenum">
               <a:rPr lang="en-IN" smtClean="0"/>
               <a:t>‹#›</a:t>
             </a:fld>
@@ -2036,7 +2036,7 @@
     </p:spTree>
     <p:extLst>
       <p:ext uri="{BB962C8B-B14F-4D97-AF65-F5344CB8AC3E}">
-        <p14:creationId xmlns:p14="http://schemas.microsoft.com/office/powerpoint/2010/main" val="1696495882"/>
+        <p14:creationId xmlns:p14="http://schemas.microsoft.com/office/powerpoint/2010/main" val="3771121983"/>
       </p:ext>
     </p:extLst>
   </p:cSld>
@@ -2068,7 +2068,7 @@
           <p:cNvPr id="2" name="Date Placeholder 1">
             <a:extLst>
               <a:ext uri="{FF2B5EF4-FFF2-40B4-BE49-F238E27FC236}">
-                <a16:creationId xmlns:a16="http://schemas.microsoft.com/office/drawing/2014/main" id="{34B9F403-78A2-2C1A-DE81-45BE4AD648C4}"/>
+                <a16:creationId xmlns:a16="http://schemas.microsoft.com/office/drawing/2014/main" id="{6E24C964-B5E4-3172-0F7F-4D39AA5BC714}"/>
               </a:ext>
             </a:extLst>
           </p:cNvPr>
@@ -2084,7 +2084,7 @@
           <a:bodyPr/>
           <a:lstStyle/>
           <a:p>
-            <a:fld id="{4416A6DF-60CD-44D2-B8D7-9C28A0EA7403}" type="datetimeFigureOut">
+            <a:fld id="{B343152C-D453-4594-B49F-69867965F11A}" type="datetimeFigureOut">
               <a:rPr lang="en-IN" smtClean="0"/>
               <a:t>16-09-2026</a:t>
             </a:fld>
@@ -2097,7 +2097,7 @@
           <p:cNvPr id="3" name="Footer Placeholder 2">
             <a:extLst>
               <a:ext uri="{FF2B5EF4-FFF2-40B4-BE49-F238E27FC236}">
-                <a16:creationId xmlns:a16="http://schemas.microsoft.com/office/drawing/2014/main" id="{032CC04E-EE57-8A30-D001-CC32E0A68C49}"/>
+                <a16:creationId xmlns:a16="http://schemas.microsoft.com/office/drawing/2014/main" id="{E58CE60A-0B2B-3A2A-E7F4-FDF5CD418C2E}"/>
               </a:ext>
             </a:extLst>
           </p:cNvPr>
@@ -2122,7 +2122,7 @@
           <p:cNvPr id="4" name="Slide Number Placeholder 3">
             <a:extLst>
               <a:ext uri="{FF2B5EF4-FFF2-40B4-BE49-F238E27FC236}">
-                <a16:creationId xmlns:a16="http://schemas.microsoft.com/office/drawing/2014/main" id="{73D3AAAD-9E52-F243-9660-63A4155A388C}"/>
+                <a16:creationId xmlns:a16="http://schemas.microsoft.com/office/drawing/2014/main" id="{83AFA1DC-B0F9-C320-2CBC-87FCEECA815B}"/>
               </a:ext>
             </a:extLst>
           </p:cNvPr>
@@ -2138,7 +2138,7 @@
           <a:bodyPr/>
           <a:lstStyle/>
           <a:p>
-            <a:fld id="{78F6A441-4E7A-4D42-B657-3B8AA7E8D50A}" type="slidenum">
+            <a:fld id="{3AB31993-B234-4B1C-A01D-03AA2FEA6D33}" type="slidenum">
               <a:rPr lang="en-IN" smtClean="0"/>
               <a:t>‹#›</a:t>
             </a:fld>
@@ -2149,7 +2149,7 @@
     </p:spTree>
     <p:extLst>
       <p:ext uri="{BB962C8B-B14F-4D97-AF65-F5344CB8AC3E}">
-        <p14:creationId xmlns:p14="http://schemas.microsoft.com/office/powerpoint/2010/main" val="1771918912"/>
+        <p14:creationId xmlns:p14="http://schemas.microsoft.com/office/powerpoint/2010/main" val="308853661"/>
       </p:ext>
     </p:extLst>
   </p:cSld>
@@ -2181,7 +2181,7 @@
           <p:cNvPr id="2" name="Title 1">
             <a:extLst>
               <a:ext uri="{FF2B5EF4-FFF2-40B4-BE49-F238E27FC236}">
-                <a16:creationId xmlns:a16="http://schemas.microsoft.com/office/drawing/2014/main" id="{BB03A59E-844E-6EAB-8F78-76D0F395CE83}"/>
+                <a16:creationId xmlns:a16="http://schemas.microsoft.com/office/drawing/2014/main" id="{3A8A8797-59D2-BEA0-41D5-9B4B7DBFB150}"/>
               </a:ext>
             </a:extLst>
           </p:cNvPr>
@@ -2219,7 +2219,7 @@
           <p:cNvPr id="3" name="Content Placeholder 2">
             <a:extLst>
               <a:ext uri="{FF2B5EF4-FFF2-40B4-BE49-F238E27FC236}">
-                <a16:creationId xmlns:a16="http://schemas.microsoft.com/office/drawing/2014/main" id="{E0023CD4-2584-6963-00FF-9F60BF204908}"/>
+                <a16:creationId xmlns:a16="http://schemas.microsoft.com/office/drawing/2014/main" id="{9ECDB1FE-68CF-DEC5-0126-366106375022}"/>
               </a:ext>
             </a:extLst>
           </p:cNvPr>
@@ -2310,7 +2310,7 @@
           <p:cNvPr id="4" name="Text Placeholder 3">
             <a:extLst>
               <a:ext uri="{FF2B5EF4-FFF2-40B4-BE49-F238E27FC236}">
-                <a16:creationId xmlns:a16="http://schemas.microsoft.com/office/drawing/2014/main" id="{B5667B87-910C-47BB-FDAF-F5CA69D57838}"/>
+                <a16:creationId xmlns:a16="http://schemas.microsoft.com/office/drawing/2014/main" id="{EC6E0D6D-548B-B449-FDFB-97D6D8D837EA}"/>
               </a:ext>
             </a:extLst>
           </p:cNvPr>
@@ -2381,7 +2381,7 @@
           <p:cNvPr id="5" name="Date Placeholder 4">
             <a:extLst>
               <a:ext uri="{FF2B5EF4-FFF2-40B4-BE49-F238E27FC236}">
-                <a16:creationId xmlns:a16="http://schemas.microsoft.com/office/drawing/2014/main" id="{C8241BE0-E0BB-130F-A1A6-E5C318C8FCF7}"/>
+                <a16:creationId xmlns:a16="http://schemas.microsoft.com/office/drawing/2014/main" id="{DF676EC6-0754-F276-0036-9CDBC34F92B8}"/>
               </a:ext>
             </a:extLst>
           </p:cNvPr>
@@ -2397,7 +2397,7 @@
           <a:bodyPr/>
           <a:lstStyle/>
           <a:p>
-            <a:fld id="{4416A6DF-60CD-44D2-B8D7-9C28A0EA7403}" type="datetimeFigureOut">
+            <a:fld id="{B343152C-D453-4594-B49F-69867965F11A}" type="datetimeFigureOut">
               <a:rPr lang="en-IN" smtClean="0"/>
               <a:t>16-09-2026</a:t>
             </a:fld>
@@ -2410,7 +2410,7 @@
           <p:cNvPr id="6" name="Footer Placeholder 5">
             <a:extLst>
               <a:ext uri="{FF2B5EF4-FFF2-40B4-BE49-F238E27FC236}">
-                <a16:creationId xmlns:a16="http://schemas.microsoft.com/office/drawing/2014/main" id="{3CC83E14-1014-4E47-75CD-A21E5AFCD2F7}"/>
+                <a16:creationId xmlns:a16="http://schemas.microsoft.com/office/drawing/2014/main" id="{ED91D7EF-8AED-14A3-CAEB-FF7C67C29A40}"/>
               </a:ext>
             </a:extLst>
           </p:cNvPr>
@@ -2435,7 +2435,7 @@
           <p:cNvPr id="7" name="Slide Number Placeholder 6">
             <a:extLst>
               <a:ext uri="{FF2B5EF4-FFF2-40B4-BE49-F238E27FC236}">
-                <a16:creationId xmlns:a16="http://schemas.microsoft.com/office/drawing/2014/main" id="{BE903AE9-D29F-0201-1329-C6A69FE04449}"/>
+                <a16:creationId xmlns:a16="http://schemas.microsoft.com/office/drawing/2014/main" id="{163851E6-9260-0C3F-DBFD-559DB56831CC}"/>
               </a:ext>
             </a:extLst>
           </p:cNvPr>
@@ -2451,7 +2451,7 @@
           <a:bodyPr/>
           <a:lstStyle/>
           <a:p>
-            <a:fld id="{78F6A441-4E7A-4D42-B657-3B8AA7E8D50A}" type="slidenum">
+            <a:fld id="{3AB31993-B234-4B1C-A01D-03AA2FEA6D33}" type="slidenum">
               <a:rPr lang="en-IN" smtClean="0"/>
               <a:t>‹#›</a:t>
             </a:fld>
@@ -2462,7 +2462,7 @@
     </p:spTree>
     <p:extLst>
       <p:ext uri="{BB962C8B-B14F-4D97-AF65-F5344CB8AC3E}">
-        <p14:creationId xmlns:p14="http://schemas.microsoft.com/office/powerpoint/2010/main" val="1587809001"/>
+        <p14:creationId xmlns:p14="http://schemas.microsoft.com/office/powerpoint/2010/main" val="1449114434"/>
       </p:ext>
     </p:extLst>
   </p:cSld>
@@ -2494,7 +2494,7 @@
           <p:cNvPr id="2" name="Title 1">
             <a:extLst>
               <a:ext uri="{FF2B5EF4-FFF2-40B4-BE49-F238E27FC236}">
-                <a16:creationId xmlns:a16="http://schemas.microsoft.com/office/drawing/2014/main" id="{24EE8DE4-48CB-6A9D-3FF0-9027EBD0AF93}"/>
+                <a16:creationId xmlns:a16="http://schemas.microsoft.com/office/drawing/2014/main" id="{94DFA27D-A8FD-3386-DD24-372BE0830ED4}"/>
               </a:ext>
             </a:extLst>
           </p:cNvPr>
@@ -2532,7 +2532,7 @@
           <p:cNvPr id="3" name="Picture Placeholder 2">
             <a:extLst>
               <a:ext uri="{FF2B5EF4-FFF2-40B4-BE49-F238E27FC236}">
-                <a16:creationId xmlns:a16="http://schemas.microsoft.com/office/drawing/2014/main" id="{46ECD5C2-32D9-C1CB-2407-0ABAF3EC1FBC}"/>
+                <a16:creationId xmlns:a16="http://schemas.microsoft.com/office/drawing/2014/main" id="{D21A5460-6C75-1846-08EF-8B95164C9472}"/>
               </a:ext>
             </a:extLst>
           </p:cNvPr>
@@ -2599,7 +2599,7 @@
           <p:cNvPr id="4" name="Text Placeholder 3">
             <a:extLst>
               <a:ext uri="{FF2B5EF4-FFF2-40B4-BE49-F238E27FC236}">
-                <a16:creationId xmlns:a16="http://schemas.microsoft.com/office/drawing/2014/main" id="{06C1F6DA-84E2-1458-388E-4AE24D3E44D7}"/>
+                <a16:creationId xmlns:a16="http://schemas.microsoft.com/office/drawing/2014/main" id="{6DC7E6FB-50B2-12BF-2BAC-4F13B702FF79}"/>
               </a:ext>
             </a:extLst>
           </p:cNvPr>
@@ -2670,7 +2670,7 @@
           <p:cNvPr id="5" name="Date Placeholder 4">
             <a:extLst>
               <a:ext uri="{FF2B5EF4-FFF2-40B4-BE49-F238E27FC236}">
-                <a16:creationId xmlns:a16="http://schemas.microsoft.com/office/drawing/2014/main" id="{1D589658-EE11-6C7E-AFE2-82F00288CD89}"/>
+                <a16:creationId xmlns:a16="http://schemas.microsoft.com/office/drawing/2014/main" id="{11216F30-53AC-F497-8F49-C6CA6F01DCF3}"/>
               </a:ext>
             </a:extLst>
           </p:cNvPr>
@@ -2686,7 +2686,7 @@
           <a:bodyPr/>
           <a:lstStyle/>
           <a:p>
-            <a:fld id="{4416A6DF-60CD-44D2-B8D7-9C28A0EA7403}" type="datetimeFigureOut">
+            <a:fld id="{B343152C-D453-4594-B49F-69867965F11A}" type="datetimeFigureOut">
               <a:rPr lang="en-IN" smtClean="0"/>
               <a:t>16-09-2026</a:t>
             </a:fld>
@@ -2699,7 +2699,7 @@
           <p:cNvPr id="6" name="Footer Placeholder 5">
             <a:extLst>
               <a:ext uri="{FF2B5EF4-FFF2-40B4-BE49-F238E27FC236}">
-                <a16:creationId xmlns:a16="http://schemas.microsoft.com/office/drawing/2014/main" id="{162B9BD0-608F-5167-D880-8A5BCCABFDC8}"/>
+                <a16:creationId xmlns:a16="http://schemas.microsoft.com/office/drawing/2014/main" id="{D8866F74-A9C7-8FF7-1475-EB00F0009478}"/>
               </a:ext>
             </a:extLst>
           </p:cNvPr>
@@ -2724,7 +2724,7 @@
           <p:cNvPr id="7" name="Slide Number Placeholder 6">
             <a:extLst>
               <a:ext uri="{FF2B5EF4-FFF2-40B4-BE49-F238E27FC236}">
-                <a16:creationId xmlns:a16="http://schemas.microsoft.com/office/drawing/2014/main" id="{3637D798-B5F6-F4ED-5396-FAD6F2D9FCB1}"/>
+                <a16:creationId xmlns:a16="http://schemas.microsoft.com/office/drawing/2014/main" id="{152D6BA5-C041-E2D1-13A7-015AB6BDB3B7}"/>
               </a:ext>
             </a:extLst>
           </p:cNvPr>
@@ -2740,7 +2740,7 @@
           <a:bodyPr/>
           <a:lstStyle/>
           <a:p>
-            <a:fld id="{78F6A441-4E7A-4D42-B657-3B8AA7E8D50A}" type="slidenum">
+            <a:fld id="{3AB31993-B234-4B1C-A01D-03AA2FEA6D33}" type="slidenum">
               <a:rPr lang="en-IN" smtClean="0"/>
               <a:t>‹#›</a:t>
             </a:fld>
@@ -2751,7 +2751,7 @@
     </p:spTree>
     <p:extLst>
       <p:ext uri="{BB962C8B-B14F-4D97-AF65-F5344CB8AC3E}">
-        <p14:creationId xmlns:p14="http://schemas.microsoft.com/office/powerpoint/2010/main" val="3466140622"/>
+        <p14:creationId xmlns:p14="http://schemas.microsoft.com/office/powerpoint/2010/main" val="2601131002"/>
       </p:ext>
     </p:extLst>
   </p:cSld>
@@ -2788,7 +2788,7 @@
           <p:cNvPr id="2" name="Title Placeholder 1">
             <a:extLst>
               <a:ext uri="{FF2B5EF4-FFF2-40B4-BE49-F238E27FC236}">
-                <a16:creationId xmlns:a16="http://schemas.microsoft.com/office/drawing/2014/main" id="{6DE09E23-C4DE-02B6-7DC0-FCE8DE345341}"/>
+                <a16:creationId xmlns:a16="http://schemas.microsoft.com/office/drawing/2014/main" id="{21F62964-2CEB-D11B-28D7-023CFFCAF3BF}"/>
               </a:ext>
             </a:extLst>
           </p:cNvPr>
@@ -2827,7 +2827,7 @@
           <p:cNvPr id="3" name="Text Placeholder 2">
             <a:extLst>
               <a:ext uri="{FF2B5EF4-FFF2-40B4-BE49-F238E27FC236}">
-                <a16:creationId xmlns:a16="http://schemas.microsoft.com/office/drawing/2014/main" id="{C64DAA44-1F8F-B60D-C99F-069AE9077437}"/>
+                <a16:creationId xmlns:a16="http://schemas.microsoft.com/office/drawing/2014/main" id="{06AA7B8D-1066-149C-61A1-A755DC568350}"/>
               </a:ext>
             </a:extLst>
           </p:cNvPr>
@@ -2895,7 +2895,7 @@
           <p:cNvPr id="4" name="Date Placeholder 3">
             <a:extLst>
               <a:ext uri="{FF2B5EF4-FFF2-40B4-BE49-F238E27FC236}">
-                <a16:creationId xmlns:a16="http://schemas.microsoft.com/office/drawing/2014/main" id="{79682D36-76C8-9BE7-FE5E-A536003CC644}"/>
+                <a16:creationId xmlns:a16="http://schemas.microsoft.com/office/drawing/2014/main" id="{B53AFEFC-58A2-3D88-08C4-AB3550AC95F7}"/>
               </a:ext>
             </a:extLst>
           </p:cNvPr>
@@ -2929,7 +2929,7 @@
             </a:lvl1pPr>
           </a:lstStyle>
           <a:p>
-            <a:fld id="{4416A6DF-60CD-44D2-B8D7-9C28A0EA7403}" type="datetimeFigureOut">
+            <a:fld id="{B343152C-D453-4594-B49F-69867965F11A}" type="datetimeFigureOut">
               <a:rPr lang="en-IN" smtClean="0"/>
               <a:t>16-09-2026</a:t>
             </a:fld>
@@ -2942,7 +2942,7 @@
           <p:cNvPr id="5" name="Footer Placeholder 4">
             <a:extLst>
               <a:ext uri="{FF2B5EF4-FFF2-40B4-BE49-F238E27FC236}">
-                <a16:creationId xmlns:a16="http://schemas.microsoft.com/office/drawing/2014/main" id="{1469686D-D2FA-D47F-DCE8-810AB5D16BD3}"/>
+                <a16:creationId xmlns:a16="http://schemas.microsoft.com/office/drawing/2014/main" id="{8232A5C8-8441-65EC-6E74-9EB2FB6E763F}"/>
               </a:ext>
             </a:extLst>
           </p:cNvPr>
@@ -2985,7 +2985,7 @@
           <p:cNvPr id="6" name="Slide Number Placeholder 5">
             <a:extLst>
               <a:ext uri="{FF2B5EF4-FFF2-40B4-BE49-F238E27FC236}">
-                <a16:creationId xmlns:a16="http://schemas.microsoft.com/office/drawing/2014/main" id="{05461102-2DE5-D0A4-1DB0-0C30F7E4C010}"/>
+                <a16:creationId xmlns:a16="http://schemas.microsoft.com/office/drawing/2014/main" id="{815C7823-8234-DEF7-5CAB-4D71A7B9AB1A}"/>
               </a:ext>
             </a:extLst>
           </p:cNvPr>
@@ -3019,7 +3019,7 @@
             </a:lvl1pPr>
           </a:lstStyle>
           <a:p>
-            <a:fld id="{78F6A441-4E7A-4D42-B657-3B8AA7E8D50A}" type="slidenum">
+            <a:fld id="{3AB31993-B234-4B1C-A01D-03AA2FEA6D33}" type="slidenum">
               <a:rPr lang="en-IN" smtClean="0"/>
               <a:t>‹#›</a:t>
             </a:fld>
@@ -3030,7 +3030,7 @@
     </p:spTree>
     <p:extLst>
       <p:ext uri="{BB962C8B-B14F-4D97-AF65-F5344CB8AC3E}">
-        <p14:creationId xmlns:p14="http://schemas.microsoft.com/office/powerpoint/2010/main" val="3578614951"/>
+        <p14:creationId xmlns:p14="http://schemas.microsoft.com/office/powerpoint/2010/main" val="3573711404"/>
       </p:ext>
     </p:extLst>
   </p:cSld>
@@ -3353,7 +3353,7 @@
           <p:cNvPr id="3" name="Picture 2">
             <a:extLst>
               <a:ext uri="{FF2B5EF4-FFF2-40B4-BE49-F238E27FC236}">
-                <a16:creationId xmlns:a16="http://schemas.microsoft.com/office/drawing/2014/main" id="{0C8F65CA-7B50-75B5-33DE-6331082CB952}"/>
+                <a16:creationId xmlns:a16="http://schemas.microsoft.com/office/drawing/2014/main" id="{A76271EE-56CC-1823-335D-D1A87C8B4DD7}"/>
               </a:ext>
             </a:extLst>
           </p:cNvPr>
@@ -3387,7 +3387,7 @@
     </p:spTree>
     <p:extLst>
       <p:ext uri="{BB962C8B-B14F-4D97-AF65-F5344CB8AC3E}">
-        <p14:creationId xmlns:p14="http://schemas.microsoft.com/office/powerpoint/2010/main" val="4167863200"/>
+        <p14:creationId xmlns:p14="http://schemas.microsoft.com/office/powerpoint/2010/main" val="1740010060"/>
       </p:ext>
     </p:extLst>
   </p:cSld>
@@ -3419,7 +3419,7 @@
           <p:cNvPr id="3" name="Picture 2">
             <a:extLst>
               <a:ext uri="{FF2B5EF4-FFF2-40B4-BE49-F238E27FC236}">
-                <a16:creationId xmlns:a16="http://schemas.microsoft.com/office/drawing/2014/main" id="{0E712F35-D6B5-6358-8094-0AAFEDE49741}"/>
+                <a16:creationId xmlns:a16="http://schemas.microsoft.com/office/drawing/2014/main" id="{C27897C9-59FA-CDE4-3CE8-1EEA39518B9F}"/>
               </a:ext>
             </a:extLst>
           </p:cNvPr>
@@ -3453,7 +3453,7 @@
     </p:spTree>
     <p:extLst>
       <p:ext uri="{BB962C8B-B14F-4D97-AF65-F5344CB8AC3E}">
-        <p14:creationId xmlns:p14="http://schemas.microsoft.com/office/powerpoint/2010/main" val="1166543672"/>
+        <p14:creationId xmlns:p14="http://schemas.microsoft.com/office/powerpoint/2010/main" val="1827856185"/>
       </p:ext>
     </p:extLst>
   </p:cSld>
@@ -3485,7 +3485,7 @@
           <p:cNvPr id="3" name="Picture 2">
             <a:extLst>
               <a:ext uri="{FF2B5EF4-FFF2-40B4-BE49-F238E27FC236}">
-                <a16:creationId xmlns:a16="http://schemas.microsoft.com/office/drawing/2014/main" id="{EBB20AFD-824E-CFC5-2218-38BBF3ED110F}"/>
+                <a16:creationId xmlns:a16="http://schemas.microsoft.com/office/drawing/2014/main" id="{2B819103-F68F-72C4-053B-82465ED40FDB}"/>
               </a:ext>
             </a:extLst>
           </p:cNvPr>
@@ -3519,7 +3519,7 @@
     </p:spTree>
     <p:extLst>
       <p:ext uri="{BB962C8B-B14F-4D97-AF65-F5344CB8AC3E}">
-        <p14:creationId xmlns:p14="http://schemas.microsoft.com/office/powerpoint/2010/main" val="220341424"/>
+        <p14:creationId xmlns:p14="http://schemas.microsoft.com/office/powerpoint/2010/main" val="1579297769"/>
       </p:ext>
     </p:extLst>
   </p:cSld>
@@ -3551,7 +3551,7 @@
           <p:cNvPr id="3" name="Picture 2">
             <a:extLst>
               <a:ext uri="{FF2B5EF4-FFF2-40B4-BE49-F238E27FC236}">
-                <a16:creationId xmlns:a16="http://schemas.microsoft.com/office/drawing/2014/main" id="{3522E53E-EB52-7B4A-CFEC-552FB0F170DB}"/>
+                <a16:creationId xmlns:a16="http://schemas.microsoft.com/office/drawing/2014/main" id="{EE48E84E-1E62-6DA1-6A62-6D3F4E4743CF}"/>
               </a:ext>
             </a:extLst>
           </p:cNvPr>
@@ -3585,7 +3585,7 @@
     </p:spTree>
     <p:extLst>
       <p:ext uri="{BB962C8B-B14F-4D97-AF65-F5344CB8AC3E}">
-        <p14:creationId xmlns:p14="http://schemas.microsoft.com/office/powerpoint/2010/main" val="3827210496"/>
+        <p14:creationId xmlns:p14="http://schemas.microsoft.com/office/powerpoint/2010/main" val="1107880068"/>
       </p:ext>
     </p:extLst>
   </p:cSld>
@@ -3617,7 +3617,7 @@
           <p:cNvPr id="3" name="Picture 2">
             <a:extLst>
               <a:ext uri="{FF2B5EF4-FFF2-40B4-BE49-F238E27FC236}">
-                <a16:creationId xmlns:a16="http://schemas.microsoft.com/office/drawing/2014/main" id="{91A72D1C-330F-B71C-DBA5-C4D6661F00C1}"/>
+                <a16:creationId xmlns:a16="http://schemas.microsoft.com/office/drawing/2014/main" id="{95CA50C3-654D-74AF-622A-9EBAF8F8FD8C}"/>
               </a:ext>
             </a:extLst>
           </p:cNvPr>
@@ -3651,7 +3651,7 @@
     </p:spTree>
     <p:extLst>
       <p:ext uri="{BB962C8B-B14F-4D97-AF65-F5344CB8AC3E}">
-        <p14:creationId xmlns:p14="http://schemas.microsoft.com/office/powerpoint/2010/main" val="3730516436"/>
+        <p14:creationId xmlns:p14="http://schemas.microsoft.com/office/powerpoint/2010/main" val="372823265"/>
       </p:ext>
     </p:extLst>
   </p:cSld>
@@ -3683,7 +3683,7 @@
           <p:cNvPr id="3" name="Picture 2">
             <a:extLst>
               <a:ext uri="{FF2B5EF4-FFF2-40B4-BE49-F238E27FC236}">
-                <a16:creationId xmlns:a16="http://schemas.microsoft.com/office/drawing/2014/main" id="{F0B2C4A0-E7E1-EC78-9B1D-C3353D66AA5D}"/>
+                <a16:creationId xmlns:a16="http://schemas.microsoft.com/office/drawing/2014/main" id="{373C8D5B-C0E7-C485-219D-3D5A81591C75}"/>
               </a:ext>
             </a:extLst>
           </p:cNvPr>
@@ -3717,7 +3717,7 @@
     </p:spTree>
     <p:extLst>
       <p:ext uri="{BB962C8B-B14F-4D97-AF65-F5344CB8AC3E}">
-        <p14:creationId xmlns:p14="http://schemas.microsoft.com/office/powerpoint/2010/main" val="1024158855"/>
+        <p14:creationId xmlns:p14="http://schemas.microsoft.com/office/powerpoint/2010/main" val="303546282"/>
       </p:ext>
     </p:extLst>
   </p:cSld>
@@ -3749,7 +3749,7 @@
           <p:cNvPr id="3" name="Picture 2">
             <a:extLst>
               <a:ext uri="{FF2B5EF4-FFF2-40B4-BE49-F238E27FC236}">
-                <a16:creationId xmlns:a16="http://schemas.microsoft.com/office/drawing/2014/main" id="{3D1D22A7-E9B4-B080-C3B2-AF68ECC1DA93}"/>
+                <a16:creationId xmlns:a16="http://schemas.microsoft.com/office/drawing/2014/main" id="{FBDD2AE6-FAAF-6D62-744F-B6DBDE9C4101}"/>
               </a:ext>
             </a:extLst>
           </p:cNvPr>
@@ -3783,7 +3783,7 @@
     </p:spTree>
     <p:extLst>
       <p:ext uri="{BB962C8B-B14F-4D97-AF65-F5344CB8AC3E}">
-        <p14:creationId xmlns:p14="http://schemas.microsoft.com/office/powerpoint/2010/main" val="329975941"/>
+        <p14:creationId xmlns:p14="http://schemas.microsoft.com/office/powerpoint/2010/main" val="3728942999"/>
       </p:ext>
     </p:extLst>
   </p:cSld>

</xml_diff>